<commit_message>
Update Zeta Sprint 2026 and gate workspace access strictly to BEX and SFE roles
</commit_message>
<xml_diff>
--- a/zeta sprint/Zeta_Sprint_2026_Complete.pptx
+++ b/zeta sprint/Zeta_Sprint_2026_Complete.pptx
@@ -17,6 +17,7 @@
     <p:sldId id="289" r:id="rId8"/>
     <p:sldId id="290" r:id="rId9"/>
     <p:sldId id="291" r:id="rId10"/>
+    <p:sldId id="305" r:id="rId37"/>
     <p:sldId id="292" r:id="rId11"/>
     <p:sldId id="293" r:id="rId12"/>
     <p:sldId id="294" r:id="rId13"/>
@@ -6428,6 +6429,1865 @@
     <p:bg>
       <p:bgPr>
         <a:solidFill>
+          <a:srgbClr val="F5F7FA"/>
+        </a:solidFill>
+        <a:effectLst/>
+      </p:bgPr>
+    </p:bg>
+    <p:spTree>
+      <p:nvGrpSpPr>
+        <p:cNvPr id="1" name="Shape 31"/>
+        <p:cNvGrpSpPr/>
+        <p:nvPr/>
+      </p:nvGrpSpPr>
+      <p:grpSpPr>
+        <a:xfrm>
+          <a:off x="0" y="0"/>
+          <a:ext cx="0" cy="0"/>
+          <a:chOff x="0" y="0"/>
+          <a:chExt cx="0" cy="0"/>
+        </a:xfrm>
+      </p:grpSpPr>
+      <p:sp>
+        <p:nvSpPr>
+          <p:cNvPr id="32" name="Google Shape;32;p4"/>
+          <p:cNvSpPr/>
+          <p:nvPr/>
+        </p:nvSpPr>
+        <p:spPr>
+          <a:xfrm>
+            <a:off x="0" y="0"/>
+            <a:ext cx="9144000" cy="868680"/>
+          </a:xfrm>
+          <a:prstGeom prst="rect">
+            <a:avLst/>
+          </a:prstGeom>
+          <a:solidFill>
+            <a:srgbClr val="0F2557"/>
+          </a:solidFill>
+          <a:ln w="12700" cap="flat" cmpd="sng">
+            <a:solidFill>
+              <a:srgbClr val="0F2557"/>
+            </a:solidFill>
+            <a:prstDash val="solid"/>
+            <a:round/>
+            <a:headEnd type="none" w="sm" len="sm"/>
+            <a:tailEnd type="none" w="sm" len="sm"/>
+          </a:ln>
+        </p:spPr>
+        <p:txBody>
+          <a:bodyPr spcFirstLastPara="1" wrap="square" lIns="91425" tIns="91425" rIns="91425" bIns="91425" anchor="ctr" anchorCtr="0">
+            <a:noAutofit/>
+          </a:bodyPr>
+          <a:lstStyle/>
+          <a:p>
+            <a:pPr marL="0" lvl="0" indent="0" algn="l" rtl="0">
+              <a:spcBef>
+                <a:spcPts val="0"/>
+              </a:spcBef>
+              <a:spcAft>
+                <a:spcPts val="0"/>
+              </a:spcAft>
+              <a:buNone/>
+            </a:pPr>
+            <a:endParaRPr/>
+          </a:p>
+        </p:txBody>
+      </p:sp>
+      <p:sp>
+        <p:nvSpPr>
+          <p:cNvPr id="33" name="Google Shape;33;p4"/>
+          <p:cNvSpPr/>
+          <p:nvPr/>
+        </p:nvSpPr>
+        <p:spPr>
+          <a:xfrm>
+            <a:off x="0" y="0"/>
+            <a:ext cx="9144000" cy="64008"/>
+          </a:xfrm>
+          <a:prstGeom prst="rect">
+            <a:avLst/>
+          </a:prstGeom>
+          <a:solidFill>
+            <a:srgbClr val="FAAD14"/>
+          </a:solidFill>
+          <a:ln w="12700" cap="flat" cmpd="sng">
+            <a:solidFill>
+              <a:srgbClr val="FAAD14"/>
+            </a:solidFill>
+            <a:prstDash val="solid"/>
+            <a:round/>
+            <a:headEnd type="none" w="sm" len="sm"/>
+            <a:tailEnd type="none" w="sm" len="sm"/>
+          </a:ln>
+        </p:spPr>
+        <p:txBody>
+          <a:bodyPr spcFirstLastPara="1" wrap="square" lIns="91425" tIns="91425" rIns="91425" bIns="91425" anchor="ctr" anchorCtr="0">
+            <a:noAutofit/>
+          </a:bodyPr>
+          <a:lstStyle/>
+          <a:p>
+            <a:pPr marL="0" lvl="0" indent="0" algn="l" rtl="0">
+              <a:spcBef>
+                <a:spcPts val="0"/>
+              </a:spcBef>
+              <a:spcAft>
+                <a:spcPts val="0"/>
+              </a:spcAft>
+              <a:buNone/>
+            </a:pPr>
+            <a:endParaRPr/>
+          </a:p>
+        </p:txBody>
+      </p:sp>
+      <p:sp>
+        <p:nvSpPr>
+          <p:cNvPr id="34" name="Google Shape;34;p4"/>
+          <p:cNvSpPr/>
+          <p:nvPr/>
+        </p:nvSpPr>
+        <p:spPr>
+          <a:xfrm>
+            <a:off x="320040" y="91440"/>
+            <a:ext cx="8503920" cy="731520"/>
+          </a:xfrm>
+          <a:prstGeom prst="rect">
+            <a:avLst/>
+          </a:prstGeom>
+          <a:noFill/>
+          <a:ln>
+            <a:noFill/>
+          </a:ln>
+        </p:spPr>
+        <p:txBody>
+          <a:bodyPr spcFirstLastPara="1" wrap="square" lIns="0" tIns="0" rIns="0" bIns="0" anchor="ctr" anchorCtr="0">
+            <a:noAutofit/>
+          </a:bodyPr>
+          <a:lstStyle/>
+          <a:p>
+            <a:pPr marL="0" marR="0" lvl="0" indent="0" algn="l" rtl="0">
+              <a:spcBef>
+                <a:spcPts val="0"/>
+              </a:spcBef>
+              <a:spcAft>
+                <a:spcPts val="0"/>
+              </a:spcAft>
+              <a:buClr>
+                <a:srgbClr val="FFFFFF"/>
+              </a:buClr>
+              <a:buSzPts val="2200"/>
+              <a:buFont typeface="Montserrat"/>
+              <a:buNone/>
+            </a:pPr>
+            <a:r>
+              <a:rPr lang="en-US" sz="2200" b="1" i="0" u="none" strike="noStrike" cap="none">
+                <a:solidFill>
+                  <a:srgbClr val="FFFFFF"/>
+                </a:solidFill>
+                <a:latin typeface="Montserrat"/>
+                <a:ea typeface="Montserrat"/>
+                <a:cs typeface="Montserrat"/>
+                <a:sym typeface="Montserrat"/>
+              </a:rPr>
+              <a:t>Winner Pool — How Winners Are Determined</a:t>
+            </a:r>
+            <a:endParaRPr sz="2200" b="0" i="0" u="none" strike="noStrike" cap="none">
+              <a:solidFill>
+                <a:schemeClr val="dk1"/>
+              </a:solidFill>
+              <a:latin typeface="Calibri"/>
+              <a:ea typeface="Calibri"/>
+              <a:cs typeface="Calibri"/>
+              <a:sym typeface="Calibri"/>
+            </a:endParaRPr>
+          </a:p>
+        </p:txBody>
+      </p:sp>
+      <p:sp>
+        <p:nvSpPr>
+          <p:cNvPr id="35" name="Google Shape;35;p4"/>
+          <p:cNvSpPr/>
+          <p:nvPr/>
+        </p:nvSpPr>
+        <p:spPr>
+          <a:xfrm>
+            <a:off x="274320" y="1005840"/>
+            <a:ext cx="4937760" cy="1097280"/>
+          </a:xfrm>
+          <a:prstGeom prst="roundRect">
+            <a:avLst>
+              <a:gd name="adj" fmla="val 6667"/>
+            </a:avLst>
+          </a:prstGeom>
+          <a:solidFill>
+            <a:srgbClr val="FFFFFF"/>
+          </a:solidFill>
+          <a:ln w="12700" cap="flat" cmpd="sng">
+            <a:solidFill>
+              <a:srgbClr val="E0E6F0"/>
+            </a:solidFill>
+            <a:prstDash val="solid"/>
+            <a:round/>
+            <a:headEnd type="none" w="sm" len="sm"/>
+            <a:tailEnd type="none" w="sm" len="sm"/>
+          </a:ln>
+          <a:effectLst>
+            <a:outerShdw blurRad="76200" dist="25400" dir="8100000" algn="bl" rotWithShape="0">
+              <a:srgbClr val="000000">
+                <a:alpha val="7843"/>
+              </a:srgbClr>
+            </a:outerShdw>
+          </a:effectLst>
+        </p:spPr>
+        <p:txBody>
+          <a:bodyPr spcFirstLastPara="1" wrap="square" lIns="91425" tIns="91425" rIns="91425" bIns="91425" anchor="ctr" anchorCtr="0">
+            <a:noAutofit/>
+          </a:bodyPr>
+          <a:lstStyle/>
+          <a:p>
+            <a:pPr marL="0" lvl="0" indent="0" algn="l" rtl="0">
+              <a:spcBef>
+                <a:spcPts val="0"/>
+              </a:spcBef>
+              <a:spcAft>
+                <a:spcPts val="0"/>
+              </a:spcAft>
+              <a:buNone/>
+            </a:pPr>
+            <a:endParaRPr/>
+          </a:p>
+        </p:txBody>
+      </p:sp>
+      <p:sp>
+        <p:nvSpPr>
+          <p:cNvPr id="36" name="Google Shape;36;p4"/>
+          <p:cNvSpPr/>
+          <p:nvPr/>
+        </p:nvSpPr>
+        <p:spPr>
+          <a:xfrm>
+            <a:off x="411480" y="1234440"/>
+            <a:ext cx="502920" cy="502920"/>
+          </a:xfrm>
+          <a:prstGeom prst="ellipse">
+            <a:avLst/>
+          </a:prstGeom>
+          <a:solidFill>
+            <a:srgbClr val="1E50C9"/>
+          </a:solidFill>
+          <a:ln w="12700" cap="flat" cmpd="sng">
+            <a:solidFill>
+              <a:srgbClr val="1E50C9"/>
+            </a:solidFill>
+            <a:prstDash val="solid"/>
+            <a:round/>
+            <a:headEnd type="none" w="sm" len="sm"/>
+            <a:tailEnd type="none" w="sm" len="sm"/>
+          </a:ln>
+        </p:spPr>
+        <p:txBody>
+          <a:bodyPr spcFirstLastPara="1" wrap="square" lIns="91425" tIns="91425" rIns="91425" bIns="91425" anchor="ctr" anchorCtr="0">
+            <a:noAutofit/>
+          </a:bodyPr>
+          <a:lstStyle/>
+          <a:p>
+            <a:pPr marL="0" lvl="0" indent="0" algn="l" rtl="0">
+              <a:spcBef>
+                <a:spcPts val="0"/>
+              </a:spcBef>
+              <a:spcAft>
+                <a:spcPts val="0"/>
+              </a:spcAft>
+              <a:buNone/>
+            </a:pPr>
+            <a:endParaRPr/>
+          </a:p>
+        </p:txBody>
+      </p:sp>
+      <p:sp>
+        <p:nvSpPr>
+          <p:cNvPr id="37" name="Google Shape;37;p4"/>
+          <p:cNvSpPr/>
+          <p:nvPr/>
+        </p:nvSpPr>
+        <p:spPr>
+          <a:xfrm>
+            <a:off x="411480" y="1234440"/>
+            <a:ext cx="502920" cy="502920"/>
+          </a:xfrm>
+          <a:prstGeom prst="rect">
+            <a:avLst/>
+          </a:prstGeom>
+          <a:noFill/>
+          <a:ln>
+            <a:noFill/>
+          </a:ln>
+        </p:spPr>
+        <p:txBody>
+          <a:bodyPr spcFirstLastPara="1" wrap="square" lIns="91425" tIns="45700" rIns="91425" bIns="45700" anchor="ctr" anchorCtr="0">
+            <a:noAutofit/>
+          </a:bodyPr>
+          <a:lstStyle/>
+          <a:p>
+            <a:pPr marL="0" marR="0" lvl="0" indent="0" algn="ctr" rtl="0">
+              <a:spcBef>
+                <a:spcPts val="0"/>
+              </a:spcBef>
+              <a:spcAft>
+                <a:spcPts val="0"/>
+              </a:spcAft>
+              <a:buClr>
+                <a:srgbClr val="000000"/>
+              </a:buClr>
+              <a:buSzPts val="1800"/>
+              <a:buFont typeface="Calibri"/>
+              <a:buNone/>
+            </a:pPr>
+            <a:r>
+              <a:rPr lang="en-US" sz="1800" b="0" i="0" u="none" strike="noStrike" cap="none">
+                <a:solidFill>
+                  <a:srgbClr val="000000"/>
+                </a:solidFill>
+                <a:latin typeface="Calibri"/>
+                <a:ea typeface="Calibri"/>
+                <a:cs typeface="Calibri"/>
+                <a:sym typeface="Calibri"/>
+              </a:rPr>
+              <a:t>🎯</a:t>
+            </a:r>
+            <a:endParaRPr sz="1800" b="0" i="0" u="none" strike="noStrike" cap="none">
+              <a:solidFill>
+                <a:schemeClr val="dk1"/>
+              </a:solidFill>
+              <a:latin typeface="Calibri"/>
+              <a:ea typeface="Calibri"/>
+              <a:cs typeface="Calibri"/>
+              <a:sym typeface="Calibri"/>
+            </a:endParaRPr>
+          </a:p>
+        </p:txBody>
+      </p:sp>
+      <p:sp>
+        <p:nvSpPr>
+          <p:cNvPr id="38" name="Google Shape;38;p4"/>
+          <p:cNvSpPr/>
+          <p:nvPr/>
+        </p:nvSpPr>
+        <p:spPr>
+          <a:xfrm>
+            <a:off x="1051560" y="1078992"/>
+            <a:ext cx="4023360" cy="347472"/>
+          </a:xfrm>
+          <a:prstGeom prst="rect">
+            <a:avLst/>
+          </a:prstGeom>
+          <a:noFill/>
+          <a:ln>
+            <a:noFill/>
+          </a:ln>
+        </p:spPr>
+        <p:txBody>
+          <a:bodyPr spcFirstLastPara="1" wrap="square" lIns="0" tIns="0" rIns="0" bIns="0" anchor="ctr" anchorCtr="0">
+            <a:noAutofit/>
+          </a:bodyPr>
+          <a:lstStyle/>
+          <a:p>
+            <a:pPr marL="0" marR="0" lvl="0" indent="0" algn="l" rtl="0">
+              <a:spcBef>
+                <a:spcPts val="0"/>
+              </a:spcBef>
+              <a:spcAft>
+                <a:spcPts val="0"/>
+              </a:spcAft>
+              <a:buClr>
+                <a:srgbClr val="1A2340"/>
+              </a:buClr>
+              <a:buSzPts val="1300"/>
+              <a:buFont typeface="Montserrat"/>
+              <a:buNone/>
+            </a:pPr>
+            <a:r>
+              <a:rPr lang="en-US" sz="1300" b="1" i="0" u="none" strike="noStrike" cap="none">
+                <a:solidFill>
+                  <a:srgbClr val="1A2340"/>
+                </a:solidFill>
+                <a:latin typeface="Montserrat"/>
+                <a:ea typeface="Montserrat"/>
+                <a:cs typeface="Montserrat"/>
+                <a:sym typeface="Montserrat"/>
+              </a:rPr>
+              <a:t>Eligibility Gate</a:t>
+            </a:r>
+            <a:endParaRPr sz="1300" b="0" i="0" u="none" strike="noStrike" cap="none">
+              <a:solidFill>
+                <a:schemeClr val="dk1"/>
+              </a:solidFill>
+              <a:latin typeface="Calibri"/>
+              <a:ea typeface="Calibri"/>
+              <a:cs typeface="Calibri"/>
+              <a:sym typeface="Calibri"/>
+            </a:endParaRPr>
+          </a:p>
+        </p:txBody>
+      </p:sp>
+      <p:sp>
+        <p:nvSpPr>
+          <p:cNvPr id="39" name="Google Shape;39;p4"/>
+          <p:cNvSpPr/>
+          <p:nvPr/>
+        </p:nvSpPr>
+        <p:spPr>
+          <a:xfrm>
+            <a:off x="1051560" y="1417320"/>
+            <a:ext cx="4023360" cy="594360"/>
+          </a:xfrm>
+          <a:prstGeom prst="rect">
+            <a:avLst/>
+          </a:prstGeom>
+          <a:noFill/>
+          <a:ln>
+            <a:noFill/>
+          </a:ln>
+        </p:spPr>
+        <p:txBody>
+          <a:bodyPr spcFirstLastPara="1" wrap="square" lIns="0" tIns="0" rIns="0" bIns="0" anchor="t" anchorCtr="0">
+            <a:noAutofit/>
+          </a:bodyPr>
+          <a:lstStyle/>
+          <a:p>
+            <a:pPr marL="0" marR="0" lvl="0" indent="0" algn="l" rtl="0">
+              <a:spcBef>
+                <a:spcPts val="0"/>
+              </a:spcBef>
+              <a:spcAft>
+                <a:spcPts val="0"/>
+              </a:spcAft>
+              <a:buClr>
+                <a:srgbClr val="37474F"/>
+              </a:buClr>
+              <a:buSzPts val="1050"/>
+              <a:buFont typeface="Open Sans"/>
+              <a:buNone/>
+            </a:pPr>
+            <a:r>
+              <a:rPr lang="en-US" sz="1050" b="0" i="0" u="none" strike="noStrike" cap="none">
+                <a:solidFill>
+                  <a:srgbClr val="37474F"/>
+                </a:solidFill>
+                <a:latin typeface="Open Sans"/>
+                <a:ea typeface="Open Sans"/>
+                <a:cs typeface="Open Sans"/>
+                <a:sym typeface="Open Sans"/>
+              </a:rPr>
+              <a:t>Rep's KPI % must meet or exceed their own Line's Average</a:t>
+            </a:r>
+            <a:endParaRPr sz="1050" b="0" i="0" u="none" strike="noStrike" cap="none">
+              <a:solidFill>
+                <a:schemeClr val="dk1"/>
+              </a:solidFill>
+              <a:latin typeface="Calibri"/>
+              <a:ea typeface="Calibri"/>
+              <a:cs typeface="Calibri"/>
+              <a:sym typeface="Calibri"/>
+            </a:endParaRPr>
+          </a:p>
+        </p:txBody>
+      </p:sp>
+      <p:sp>
+        <p:nvSpPr>
+          <p:cNvPr id="40" name="Google Shape;40;p4"/>
+          <p:cNvSpPr/>
+          <p:nvPr/>
+        </p:nvSpPr>
+        <p:spPr>
+          <a:xfrm>
+            <a:off x="274320" y="1005840"/>
+            <a:ext cx="54864" cy="1097280"/>
+          </a:xfrm>
+          <a:prstGeom prst="rect">
+            <a:avLst/>
+          </a:prstGeom>
+          <a:solidFill>
+            <a:srgbClr val="0F2557"/>
+          </a:solidFill>
+          <a:ln w="12700" cap="flat" cmpd="sng">
+            <a:solidFill>
+              <a:srgbClr val="0F2557"/>
+            </a:solidFill>
+            <a:prstDash val="solid"/>
+            <a:round/>
+            <a:headEnd type="none" w="sm" len="sm"/>
+            <a:tailEnd type="none" w="sm" len="sm"/>
+          </a:ln>
+        </p:spPr>
+        <p:txBody>
+          <a:bodyPr spcFirstLastPara="1" wrap="square" lIns="91425" tIns="91425" rIns="91425" bIns="91425" anchor="ctr" anchorCtr="0">
+            <a:noAutofit/>
+          </a:bodyPr>
+          <a:lstStyle/>
+          <a:p>
+            <a:pPr marL="0" lvl="0" indent="0" algn="l" rtl="0">
+              <a:spcBef>
+                <a:spcPts val="0"/>
+              </a:spcBef>
+              <a:spcAft>
+                <a:spcPts val="0"/>
+              </a:spcAft>
+              <a:buNone/>
+            </a:pPr>
+            <a:endParaRPr/>
+          </a:p>
+        </p:txBody>
+      </p:sp>
+      <p:sp>
+        <p:nvSpPr>
+          <p:cNvPr id="41" name="Google Shape;41;p4"/>
+          <p:cNvSpPr/>
+          <p:nvPr/>
+        </p:nvSpPr>
+        <p:spPr>
+          <a:xfrm>
+            <a:off x="274320" y="2240280"/>
+            <a:ext cx="4937760" cy="1097280"/>
+          </a:xfrm>
+          <a:prstGeom prst="roundRect">
+            <a:avLst>
+              <a:gd name="adj" fmla="val 6667"/>
+            </a:avLst>
+          </a:prstGeom>
+          <a:solidFill>
+            <a:srgbClr val="FFFFFF"/>
+          </a:solidFill>
+          <a:ln w="12700" cap="flat" cmpd="sng">
+            <a:solidFill>
+              <a:srgbClr val="E0E6F0"/>
+            </a:solidFill>
+            <a:prstDash val="solid"/>
+            <a:round/>
+            <a:headEnd type="none" w="sm" len="sm"/>
+            <a:tailEnd type="none" w="sm" len="sm"/>
+          </a:ln>
+          <a:effectLst>
+            <a:outerShdw blurRad="76200" dist="25400" dir="8100000" algn="bl" rotWithShape="0">
+              <a:srgbClr val="000000">
+                <a:alpha val="7843"/>
+              </a:srgbClr>
+            </a:outerShdw>
+          </a:effectLst>
+        </p:spPr>
+        <p:txBody>
+          <a:bodyPr spcFirstLastPara="1" wrap="square" lIns="91425" tIns="91425" rIns="91425" bIns="91425" anchor="ctr" anchorCtr="0">
+            <a:noAutofit/>
+          </a:bodyPr>
+          <a:lstStyle/>
+          <a:p>
+            <a:pPr marL="0" lvl="0" indent="0" algn="l" rtl="0">
+              <a:spcBef>
+                <a:spcPts val="0"/>
+              </a:spcBef>
+              <a:spcAft>
+                <a:spcPts val="0"/>
+              </a:spcAft>
+              <a:buNone/>
+            </a:pPr>
+            <a:endParaRPr/>
+          </a:p>
+        </p:txBody>
+      </p:sp>
+      <p:sp>
+        <p:nvSpPr>
+          <p:cNvPr id="42" name="Google Shape;42;p4"/>
+          <p:cNvSpPr/>
+          <p:nvPr/>
+        </p:nvSpPr>
+        <p:spPr>
+          <a:xfrm>
+            <a:off x="411480" y="2468880"/>
+            <a:ext cx="502920" cy="502920"/>
+          </a:xfrm>
+          <a:prstGeom prst="ellipse">
+            <a:avLst/>
+          </a:prstGeom>
+          <a:solidFill>
+            <a:srgbClr val="1E50C9"/>
+          </a:solidFill>
+          <a:ln w="12700" cap="flat" cmpd="sng">
+            <a:solidFill>
+              <a:srgbClr val="1E50C9"/>
+            </a:solidFill>
+            <a:prstDash val="solid"/>
+            <a:round/>
+            <a:headEnd type="none" w="sm" len="sm"/>
+            <a:tailEnd type="none" w="sm" len="sm"/>
+          </a:ln>
+        </p:spPr>
+        <p:txBody>
+          <a:bodyPr spcFirstLastPara="1" wrap="square" lIns="91425" tIns="91425" rIns="91425" bIns="91425" anchor="ctr" anchorCtr="0">
+            <a:noAutofit/>
+          </a:bodyPr>
+          <a:lstStyle/>
+          <a:p>
+            <a:pPr marL="0" lvl="0" indent="0" algn="l" rtl="0">
+              <a:spcBef>
+                <a:spcPts val="0"/>
+              </a:spcBef>
+              <a:spcAft>
+                <a:spcPts val="0"/>
+              </a:spcAft>
+              <a:buNone/>
+            </a:pPr>
+            <a:endParaRPr/>
+          </a:p>
+        </p:txBody>
+      </p:sp>
+      <p:sp>
+        <p:nvSpPr>
+          <p:cNvPr id="43" name="Google Shape;43;p4"/>
+          <p:cNvSpPr/>
+          <p:nvPr/>
+        </p:nvSpPr>
+        <p:spPr>
+          <a:xfrm>
+            <a:off x="411480" y="2468880"/>
+            <a:ext cx="502920" cy="502920"/>
+          </a:xfrm>
+          <a:prstGeom prst="rect">
+            <a:avLst/>
+          </a:prstGeom>
+          <a:noFill/>
+          <a:ln>
+            <a:noFill/>
+          </a:ln>
+        </p:spPr>
+        <p:txBody>
+          <a:bodyPr spcFirstLastPara="1" wrap="square" lIns="91425" tIns="45700" rIns="91425" bIns="45700" anchor="ctr" anchorCtr="0">
+            <a:noAutofit/>
+          </a:bodyPr>
+          <a:lstStyle/>
+          <a:p>
+            <a:pPr marL="0" marR="0" lvl="0" indent="0" algn="ctr" rtl="0">
+              <a:spcBef>
+                <a:spcPts val="0"/>
+              </a:spcBef>
+              <a:spcAft>
+                <a:spcPts val="0"/>
+              </a:spcAft>
+              <a:buClr>
+                <a:srgbClr val="000000"/>
+              </a:buClr>
+              <a:buSzPts val="1800"/>
+              <a:buFont typeface="Calibri"/>
+              <a:buNone/>
+            </a:pPr>
+            <a:r>
+              <a:rPr lang="en-US" sz="1800" b="0" i="0" u="none" strike="noStrike" cap="none">
+                <a:solidFill>
+                  <a:srgbClr val="000000"/>
+                </a:solidFill>
+                <a:latin typeface="Calibri"/>
+                <a:ea typeface="Calibri"/>
+                <a:cs typeface="Calibri"/>
+                <a:sym typeface="Calibri"/>
+              </a:rPr>
+              <a:t>📋</a:t>
+            </a:r>
+            <a:endParaRPr sz="1800" b="0" i="0" u="none" strike="noStrike" cap="none">
+              <a:solidFill>
+                <a:schemeClr val="dk1"/>
+              </a:solidFill>
+              <a:latin typeface="Calibri"/>
+              <a:ea typeface="Calibri"/>
+              <a:cs typeface="Calibri"/>
+              <a:sym typeface="Calibri"/>
+            </a:endParaRPr>
+          </a:p>
+        </p:txBody>
+      </p:sp>
+      <p:sp>
+        <p:nvSpPr>
+          <p:cNvPr id="44" name="Google Shape;44;p4"/>
+          <p:cNvSpPr/>
+          <p:nvPr/>
+        </p:nvSpPr>
+        <p:spPr>
+          <a:xfrm>
+            <a:off x="1051560" y="2313432"/>
+            <a:ext cx="4023360" cy="347472"/>
+          </a:xfrm>
+          <a:prstGeom prst="rect">
+            <a:avLst/>
+          </a:prstGeom>
+          <a:noFill/>
+          <a:ln>
+            <a:noFill/>
+          </a:ln>
+        </p:spPr>
+        <p:txBody>
+          <a:bodyPr spcFirstLastPara="1" wrap="square" lIns="0" tIns="0" rIns="0" bIns="0" anchor="ctr" anchorCtr="0">
+            <a:noAutofit/>
+          </a:bodyPr>
+          <a:lstStyle/>
+          <a:p>
+            <a:pPr marL="0" marR="0" lvl="0" indent="0" algn="l" rtl="0">
+              <a:spcBef>
+                <a:spcPts val="0"/>
+              </a:spcBef>
+              <a:spcAft>
+                <a:spcPts val="0"/>
+              </a:spcAft>
+              <a:buClr>
+                <a:srgbClr val="1A2340"/>
+              </a:buClr>
+              <a:buSzPts val="1300"/>
+              <a:buFont typeface="Montserrat"/>
+              <a:buNone/>
+            </a:pPr>
+            <a:r>
+              <a:rPr lang="en-US" sz="1300" b="1" i="0" u="none" strike="noStrike" cap="none">
+                <a:solidFill>
+                  <a:srgbClr val="1A2340"/>
+                </a:solidFill>
+                <a:latin typeface="Montserrat"/>
+                <a:ea typeface="Montserrat"/>
+                <a:cs typeface="Montserrat"/>
+                <a:sym typeface="Montserrat"/>
+              </a:rPr>
+              <a:t>Required KPIs by Role</a:t>
+            </a:r>
+            <a:endParaRPr sz="1300" b="0" i="0" u="none" strike="noStrike" cap="none">
+              <a:solidFill>
+                <a:schemeClr val="dk1"/>
+              </a:solidFill>
+              <a:latin typeface="Calibri"/>
+              <a:ea typeface="Calibri"/>
+              <a:cs typeface="Calibri"/>
+              <a:sym typeface="Calibri"/>
+            </a:endParaRPr>
+          </a:p>
+        </p:txBody>
+      </p:sp>
+      <p:sp>
+        <p:nvSpPr>
+          <p:cNvPr id="45" name="Google Shape;45;p4"/>
+          <p:cNvSpPr/>
+          <p:nvPr/>
+        </p:nvSpPr>
+        <p:spPr>
+          <a:xfrm>
+            <a:off x="1051560" y="2651760"/>
+            <a:ext cx="4023360" cy="594360"/>
+          </a:xfrm>
+          <a:prstGeom prst="rect">
+            <a:avLst/>
+          </a:prstGeom>
+          <a:noFill/>
+          <a:ln>
+            <a:noFill/>
+          </a:ln>
+        </p:spPr>
+        <p:txBody>
+          <a:bodyPr spcFirstLastPara="1" wrap="square" lIns="0" tIns="0" rIns="0" bIns="0" anchor="t" anchorCtr="0">
+            <a:noAutofit/>
+          </a:bodyPr>
+          <a:lstStyle/>
+          <a:p>
+            <a:pPr marL="0" marR="0" lvl="0" indent="0" algn="l" rtl="0">
+              <a:spcBef>
+                <a:spcPts val="0"/>
+              </a:spcBef>
+              <a:spcAft>
+                <a:spcPts val="0"/>
+              </a:spcAft>
+              <a:buClr>
+                <a:srgbClr val="37474F"/>
+              </a:buClr>
+              <a:buSzPts val="1050"/>
+              <a:buFont typeface="Open Sans"/>
+              <a:buNone/>
+            </a:pPr>
+            <a:r>
+              <a:rPr lang="en-US" sz="1050" b="0" i="0" u="none" strike="noStrike" cap="none">
+                <a:solidFill>
+                  <a:srgbClr val="37474F"/>
+                </a:solidFill>
+                <a:latin typeface="Open Sans"/>
+                <a:ea typeface="Open Sans"/>
+                <a:cs typeface="Open Sans"/>
+                <a:sym typeface="Open Sans"/>
+              </a:rPr>
+              <a:t>Medical Rep: Sales + Right Frequency + Coverage (all 3)</a:t>
+            </a:r>
+            <a:endParaRPr sz="1050" b="0" i="0" u="none" strike="noStrike" cap="none">
+              <a:solidFill>
+                <a:schemeClr val="dk1"/>
+              </a:solidFill>
+              <a:latin typeface="Calibri"/>
+              <a:ea typeface="Calibri"/>
+              <a:cs typeface="Calibri"/>
+              <a:sym typeface="Calibri"/>
+            </a:endParaRPr>
+          </a:p>
+          <a:p>
+            <a:pPr marL="0" marR="0" lvl="0" indent="0" algn="l" rtl="0">
+              <a:spcBef>
+                <a:spcPts val="0"/>
+              </a:spcBef>
+              <a:spcAft>
+                <a:spcPts val="0"/>
+              </a:spcAft>
+              <a:buClr>
+                <a:srgbClr val="37474F"/>
+              </a:buClr>
+              <a:buSzPts val="1050"/>
+              <a:buFont typeface="Open Sans"/>
+              <a:buNone/>
+            </a:pPr>
+            <a:r>
+              <a:rPr lang="en-US" sz="1050" b="0" i="0" u="none" strike="noStrike" cap="none">
+                <a:solidFill>
+                  <a:srgbClr val="37474F"/>
+                </a:solidFill>
+                <a:latin typeface="Open Sans"/>
+                <a:ea typeface="Open Sans"/>
+                <a:cs typeface="Open Sans"/>
+                <a:sym typeface="Open Sans"/>
+              </a:rPr>
+              <a:t>CHC Sales Rep: Sales + Coverage only (no Right Frequency)</a:t>
+            </a:r>
+            <a:endParaRPr sz="1050" b="0" i="0" u="none" strike="noStrike" cap="none">
+              <a:solidFill>
+                <a:schemeClr val="dk1"/>
+              </a:solidFill>
+              <a:latin typeface="Calibri"/>
+              <a:ea typeface="Calibri"/>
+              <a:cs typeface="Calibri"/>
+              <a:sym typeface="Calibri"/>
+            </a:endParaRPr>
+          </a:p>
+        </p:txBody>
+      </p:sp>
+      <p:sp>
+        <p:nvSpPr>
+          <p:cNvPr id="46" name="Google Shape;46;p4"/>
+          <p:cNvSpPr/>
+          <p:nvPr/>
+        </p:nvSpPr>
+        <p:spPr>
+          <a:xfrm>
+            <a:off x="274320" y="2240280"/>
+            <a:ext cx="54864" cy="1097280"/>
+          </a:xfrm>
+          <a:prstGeom prst="rect">
+            <a:avLst/>
+          </a:prstGeom>
+          <a:solidFill>
+            <a:srgbClr val="0F2557"/>
+          </a:solidFill>
+          <a:ln w="12700" cap="flat" cmpd="sng">
+            <a:solidFill>
+              <a:srgbClr val="0F2557"/>
+            </a:solidFill>
+            <a:prstDash val="solid"/>
+            <a:round/>
+            <a:headEnd type="none" w="sm" len="sm"/>
+            <a:tailEnd type="none" w="sm" len="sm"/>
+          </a:ln>
+        </p:spPr>
+        <p:txBody>
+          <a:bodyPr spcFirstLastPara="1" wrap="square" lIns="91425" tIns="91425" rIns="91425" bIns="91425" anchor="ctr" anchorCtr="0">
+            <a:noAutofit/>
+          </a:bodyPr>
+          <a:lstStyle/>
+          <a:p>
+            <a:pPr marL="0" lvl="0" indent="0" algn="l" rtl="0">
+              <a:spcBef>
+                <a:spcPts val="0"/>
+              </a:spcBef>
+              <a:spcAft>
+                <a:spcPts val="0"/>
+              </a:spcAft>
+              <a:buNone/>
+            </a:pPr>
+            <a:endParaRPr/>
+          </a:p>
+        </p:txBody>
+      </p:sp>
+      <p:sp>
+        <p:nvSpPr>
+          <p:cNvPr id="47" name="Google Shape;47;p4"/>
+          <p:cNvSpPr/>
+          <p:nvPr/>
+        </p:nvSpPr>
+        <p:spPr>
+          <a:xfrm>
+            <a:off x="274320" y="3474720"/>
+            <a:ext cx="4937760" cy="1097280"/>
+          </a:xfrm>
+          <a:prstGeom prst="roundRect">
+            <a:avLst>
+              <a:gd name="adj" fmla="val 6667"/>
+            </a:avLst>
+          </a:prstGeom>
+          <a:solidFill>
+            <a:srgbClr val="FFFFFF"/>
+          </a:solidFill>
+          <a:ln w="12700" cap="flat" cmpd="sng">
+            <a:solidFill>
+              <a:srgbClr val="E0E6F0"/>
+            </a:solidFill>
+            <a:prstDash val="solid"/>
+            <a:round/>
+            <a:headEnd type="none" w="sm" len="sm"/>
+            <a:tailEnd type="none" w="sm" len="sm"/>
+          </a:ln>
+          <a:effectLst>
+            <a:outerShdw blurRad="76200" dist="25400" dir="8100000" algn="bl" rotWithShape="0">
+              <a:srgbClr val="000000">
+                <a:alpha val="7843"/>
+              </a:srgbClr>
+            </a:outerShdw>
+          </a:effectLst>
+        </p:spPr>
+        <p:txBody>
+          <a:bodyPr spcFirstLastPara="1" wrap="square" lIns="91425" tIns="91425" rIns="91425" bIns="91425" anchor="ctr" anchorCtr="0">
+            <a:noAutofit/>
+          </a:bodyPr>
+          <a:lstStyle/>
+          <a:p>
+            <a:pPr marL="0" lvl="0" indent="0" algn="l" rtl="0">
+              <a:spcBef>
+                <a:spcPts val="0"/>
+              </a:spcBef>
+              <a:spcAft>
+                <a:spcPts val="0"/>
+              </a:spcAft>
+              <a:buNone/>
+            </a:pPr>
+            <a:endParaRPr/>
+          </a:p>
+        </p:txBody>
+      </p:sp>
+      <p:sp>
+        <p:nvSpPr>
+          <p:cNvPr id="48" name="Google Shape;48;p4"/>
+          <p:cNvSpPr/>
+          <p:nvPr/>
+        </p:nvSpPr>
+        <p:spPr>
+          <a:xfrm>
+            <a:off x="411480" y="3703320"/>
+            <a:ext cx="502920" cy="502920"/>
+          </a:xfrm>
+          <a:prstGeom prst="ellipse">
+            <a:avLst/>
+          </a:prstGeom>
+          <a:solidFill>
+            <a:srgbClr val="1E50C9"/>
+          </a:solidFill>
+          <a:ln w="12700" cap="flat" cmpd="sng">
+            <a:solidFill>
+              <a:srgbClr val="1E50C9"/>
+            </a:solidFill>
+            <a:prstDash val="solid"/>
+            <a:round/>
+            <a:headEnd type="none" w="sm" len="sm"/>
+            <a:tailEnd type="none" w="sm" len="sm"/>
+          </a:ln>
+        </p:spPr>
+        <p:txBody>
+          <a:bodyPr spcFirstLastPara="1" wrap="square" lIns="91425" tIns="91425" rIns="91425" bIns="91425" anchor="ctr" anchorCtr="0">
+            <a:noAutofit/>
+          </a:bodyPr>
+          <a:lstStyle/>
+          <a:p>
+            <a:pPr marL="0" lvl="0" indent="0" algn="l" rtl="0">
+              <a:spcBef>
+                <a:spcPts val="0"/>
+              </a:spcBef>
+              <a:spcAft>
+                <a:spcPts val="0"/>
+              </a:spcAft>
+              <a:buNone/>
+            </a:pPr>
+            <a:endParaRPr/>
+          </a:p>
+        </p:txBody>
+      </p:sp>
+      <p:sp>
+        <p:nvSpPr>
+          <p:cNvPr id="49" name="Google Shape;49;p4"/>
+          <p:cNvSpPr/>
+          <p:nvPr/>
+        </p:nvSpPr>
+        <p:spPr>
+          <a:xfrm>
+            <a:off x="411480" y="3703320"/>
+            <a:ext cx="502920" cy="502920"/>
+          </a:xfrm>
+          <a:prstGeom prst="rect">
+            <a:avLst/>
+          </a:prstGeom>
+          <a:noFill/>
+          <a:ln>
+            <a:noFill/>
+          </a:ln>
+        </p:spPr>
+        <p:txBody>
+          <a:bodyPr spcFirstLastPara="1" wrap="square" lIns="91425" tIns="45700" rIns="91425" bIns="45700" anchor="ctr" anchorCtr="0">
+            <a:noAutofit/>
+          </a:bodyPr>
+          <a:lstStyle/>
+          <a:p>
+            <a:pPr marL="0" marR="0" lvl="0" indent="0" algn="ctr" rtl="0">
+              <a:spcBef>
+                <a:spcPts val="0"/>
+              </a:spcBef>
+              <a:spcAft>
+                <a:spcPts val="0"/>
+              </a:spcAft>
+              <a:buClr>
+                <a:srgbClr val="000000"/>
+              </a:buClr>
+              <a:buSzPts val="1800"/>
+              <a:buFont typeface="Calibri"/>
+              <a:buNone/>
+            </a:pPr>
+            <a:r>
+              <a:rPr lang="en-US" sz="1800" b="0" i="0" u="none" strike="noStrike" cap="none">
+                <a:solidFill>
+                  <a:srgbClr val="000000"/>
+                </a:solidFill>
+                <a:latin typeface="Calibri"/>
+                <a:ea typeface="Calibri"/>
+                <a:cs typeface="Calibri"/>
+                <a:sym typeface="Calibri"/>
+              </a:rPr>
+              <a:t>🤝</a:t>
+            </a:r>
+            <a:endParaRPr sz="1800" b="0" i="0" u="none" strike="noStrike" cap="none">
+              <a:solidFill>
+                <a:schemeClr val="dk1"/>
+              </a:solidFill>
+              <a:latin typeface="Calibri"/>
+              <a:ea typeface="Calibri"/>
+              <a:cs typeface="Calibri"/>
+              <a:sym typeface="Calibri"/>
+            </a:endParaRPr>
+          </a:p>
+        </p:txBody>
+      </p:sp>
+      <p:sp>
+        <p:nvSpPr>
+          <p:cNvPr id="50" name="Google Shape;50;p4"/>
+          <p:cNvSpPr/>
+          <p:nvPr/>
+        </p:nvSpPr>
+        <p:spPr>
+          <a:xfrm>
+            <a:off x="1051560" y="3547872"/>
+            <a:ext cx="4023360" cy="347472"/>
+          </a:xfrm>
+          <a:prstGeom prst="rect">
+            <a:avLst/>
+          </a:prstGeom>
+          <a:noFill/>
+          <a:ln>
+            <a:noFill/>
+          </a:ln>
+        </p:spPr>
+        <p:txBody>
+          <a:bodyPr spcFirstLastPara="1" wrap="square" lIns="0" tIns="0" rIns="0" bIns="0" anchor="ctr" anchorCtr="0">
+            <a:noAutofit/>
+          </a:bodyPr>
+          <a:lstStyle/>
+          <a:p>
+            <a:pPr marL="0" marR="0" lvl="0" indent="0" algn="l" rtl="0">
+              <a:spcBef>
+                <a:spcPts val="0"/>
+              </a:spcBef>
+              <a:spcAft>
+                <a:spcPts val="0"/>
+              </a:spcAft>
+              <a:buClr>
+                <a:srgbClr val="1A2340"/>
+              </a:buClr>
+              <a:buSzPts val="1300"/>
+              <a:buFont typeface="Montserrat"/>
+              <a:buNone/>
+            </a:pPr>
+            <a:r>
+              <a:rPr lang="en-US" sz="1300" b="1" i="0" u="none" strike="noStrike" cap="none">
+                <a:solidFill>
+                  <a:srgbClr val="1A2340"/>
+                </a:solidFill>
+                <a:latin typeface="Montserrat"/>
+                <a:ea typeface="Montserrat"/>
+                <a:cs typeface="Montserrat"/>
+                <a:sym typeface="Montserrat"/>
+              </a:rPr>
+              <a:t>Ranking &amp; Tie Rule</a:t>
+            </a:r>
+            <a:endParaRPr sz="1300" b="0" i="0" u="none" strike="noStrike" cap="none">
+              <a:solidFill>
+                <a:schemeClr val="dk1"/>
+              </a:solidFill>
+              <a:latin typeface="Calibri"/>
+              <a:ea typeface="Calibri"/>
+              <a:cs typeface="Calibri"/>
+              <a:sym typeface="Calibri"/>
+            </a:endParaRPr>
+          </a:p>
+        </p:txBody>
+      </p:sp>
+      <p:sp>
+        <p:nvSpPr>
+          <p:cNvPr id="51" name="Google Shape;51;p4"/>
+          <p:cNvSpPr/>
+          <p:nvPr/>
+        </p:nvSpPr>
+        <p:spPr>
+          <a:xfrm>
+            <a:off x="1051560" y="3886200"/>
+            <a:ext cx="4023360" cy="594360"/>
+          </a:xfrm>
+          <a:prstGeom prst="rect">
+            <a:avLst/>
+          </a:prstGeom>
+          <a:noFill/>
+          <a:ln>
+            <a:noFill/>
+          </a:ln>
+        </p:spPr>
+        <p:txBody>
+          <a:bodyPr spcFirstLastPara="1" wrap="square" lIns="0" tIns="0" rIns="0" bIns="0" anchor="t" anchorCtr="0">
+            <a:noAutofit/>
+          </a:bodyPr>
+          <a:lstStyle/>
+          <a:p>
+            <a:pPr marL="0" marR="0" lvl="0" indent="0" algn="l" rtl="0">
+              <a:spcBef>
+                <a:spcPts val="0"/>
+              </a:spcBef>
+              <a:spcAft>
+                <a:spcPts val="0"/>
+              </a:spcAft>
+              <a:buClr>
+                <a:srgbClr val="37474F"/>
+              </a:buClr>
+              <a:buSzPts val="1050"/>
+              <a:buFont typeface="Open Sans"/>
+              <a:buNone/>
+            </a:pPr>
+            <a:r>
+              <a:rPr lang="en-US" sz="1050" b="0" i="0" u="none" strike="noStrike" cap="none">
+                <a:solidFill>
+                  <a:srgbClr val="37474F"/>
+                </a:solidFill>
+                <a:latin typeface="Open Sans"/>
+                <a:ea typeface="Open Sans"/>
+                <a:cs typeface="Open Sans"/>
+                <a:sym typeface="Open Sans"/>
+              </a:rPr>
+              <a:t>Top 2 per Line by Points win; a tied Runner-Up becomes Co-Winner</a:t>
+            </a:r>
+            <a:endParaRPr sz="1050" b="0" i="0" u="none" strike="noStrike" cap="none">
+              <a:solidFill>
+                <a:schemeClr val="dk1"/>
+              </a:solidFill>
+              <a:latin typeface="Calibri"/>
+              <a:ea typeface="Calibri"/>
+              <a:cs typeface="Calibri"/>
+              <a:sym typeface="Calibri"/>
+            </a:endParaRPr>
+          </a:p>
+        </p:txBody>
+      </p:sp>
+      <p:sp>
+        <p:nvSpPr>
+          <p:cNvPr id="52" name="Google Shape;52;p4"/>
+          <p:cNvSpPr/>
+          <p:nvPr/>
+        </p:nvSpPr>
+        <p:spPr>
+          <a:xfrm>
+            <a:off x="274320" y="3474720"/>
+            <a:ext cx="54864" cy="1097280"/>
+          </a:xfrm>
+          <a:prstGeom prst="rect">
+            <a:avLst/>
+          </a:prstGeom>
+          <a:solidFill>
+            <a:srgbClr val="0F2557"/>
+          </a:solidFill>
+          <a:ln w="12700" cap="flat" cmpd="sng">
+            <a:solidFill>
+              <a:srgbClr val="0F2557"/>
+            </a:solidFill>
+            <a:prstDash val="solid"/>
+            <a:round/>
+            <a:headEnd type="none" w="sm" len="sm"/>
+            <a:tailEnd type="none" w="sm" len="sm"/>
+          </a:ln>
+        </p:spPr>
+        <p:txBody>
+          <a:bodyPr spcFirstLastPara="1" wrap="square" lIns="91425" tIns="91425" rIns="91425" bIns="91425" anchor="ctr" anchorCtr="0">
+            <a:noAutofit/>
+          </a:bodyPr>
+          <a:lstStyle/>
+          <a:p>
+            <a:pPr marL="0" lvl="0" indent="0" algn="l" rtl="0">
+              <a:spcBef>
+                <a:spcPts val="0"/>
+              </a:spcBef>
+              <a:spcAft>
+                <a:spcPts val="0"/>
+              </a:spcAft>
+              <a:buNone/>
+            </a:pPr>
+            <a:endParaRPr/>
+          </a:p>
+        </p:txBody>
+      </p:sp>
+      <p:sp>
+        <p:nvSpPr>
+          <p:cNvPr id="53" name="Google Shape;53;p4"/>
+          <p:cNvSpPr/>
+          <p:nvPr/>
+        </p:nvSpPr>
+        <p:spPr>
+          <a:xfrm>
+            <a:off x="5394960" y="1005840"/>
+            <a:ext cx="3474720" cy="1828800"/>
+          </a:xfrm>
+          <a:prstGeom prst="roundRect">
+            <a:avLst>
+              <a:gd name="adj" fmla="val 4000"/>
+            </a:avLst>
+          </a:prstGeom>
+          <a:solidFill>
+            <a:srgbClr val="FFFFFF"/>
+          </a:solidFill>
+          <a:ln w="12700" cap="flat" cmpd="sng">
+            <a:solidFill>
+              <a:srgbClr val="E0E6F0"/>
+            </a:solidFill>
+            <a:prstDash val="solid"/>
+            <a:round/>
+            <a:headEnd type="none" w="sm" len="sm"/>
+            <a:tailEnd type="none" w="sm" len="sm"/>
+          </a:ln>
+          <a:effectLst>
+            <a:outerShdw blurRad="76200" dist="25400" dir="8100000" algn="bl" rotWithShape="0">
+              <a:srgbClr val="000000">
+                <a:alpha val="7843"/>
+              </a:srgbClr>
+            </a:outerShdw>
+          </a:effectLst>
+        </p:spPr>
+        <p:txBody>
+          <a:bodyPr spcFirstLastPara="1" wrap="square" lIns="91425" tIns="91425" rIns="91425" bIns="91425" anchor="ctr" anchorCtr="0">
+            <a:noAutofit/>
+          </a:bodyPr>
+          <a:lstStyle/>
+          <a:p>
+            <a:pPr marL="0" lvl="0" indent="0" algn="l" rtl="0">
+              <a:spcBef>
+                <a:spcPts val="0"/>
+              </a:spcBef>
+              <a:spcAft>
+                <a:spcPts val="0"/>
+              </a:spcAft>
+              <a:buNone/>
+            </a:pPr>
+            <a:endParaRPr/>
+          </a:p>
+        </p:txBody>
+      </p:sp>
+      <p:sp>
+        <p:nvSpPr>
+          <p:cNvPr id="54" name="Google Shape;54;p4"/>
+          <p:cNvSpPr/>
+          <p:nvPr/>
+        </p:nvSpPr>
+        <p:spPr>
+          <a:xfrm>
+            <a:off x="5486400" y="1051560"/>
+            <a:ext cx="3291840" cy="347472"/>
+          </a:xfrm>
+          <a:prstGeom prst="rect">
+            <a:avLst/>
+          </a:prstGeom>
+          <a:noFill/>
+          <a:ln>
+            <a:noFill/>
+          </a:ln>
+        </p:spPr>
+        <p:txBody>
+          <a:bodyPr spcFirstLastPara="1" wrap="square" lIns="0" tIns="0" rIns="0" bIns="0" anchor="ctr" anchorCtr="0">
+            <a:noAutofit/>
+          </a:bodyPr>
+          <a:lstStyle/>
+          <a:p>
+            <a:pPr marL="0" marR="0" lvl="0" indent="0" algn="l" rtl="0">
+              <a:spcBef>
+                <a:spcPts val="0"/>
+              </a:spcBef>
+              <a:spcAft>
+                <a:spcPts val="0"/>
+              </a:spcAft>
+              <a:buClr>
+                <a:srgbClr val="0F2557"/>
+              </a:buClr>
+              <a:buSzPts val="1200"/>
+              <a:buFont typeface="Montserrat"/>
+              <a:buNone/>
+            </a:pPr>
+            <a:r>
+              <a:rPr lang="en-US" sz="1200" b="1" i="0" u="none" strike="noStrike" cap="none">
+                <a:solidFill>
+                  <a:srgbClr val="0F2557"/>
+                </a:solidFill>
+                <a:latin typeface="Montserrat"/>
+                <a:ea typeface="Montserrat"/>
+                <a:cs typeface="Montserrat"/>
+                <a:sym typeface="Montserrat"/>
+              </a:rPr>
+              <a:t>How Winner Pool Works</a:t>
+            </a:r>
+            <a:endParaRPr sz="1200" b="0" i="0" u="none" strike="noStrike" cap="none">
+              <a:solidFill>
+                <a:schemeClr val="dk1"/>
+              </a:solidFill>
+              <a:latin typeface="Calibri"/>
+              <a:ea typeface="Calibri"/>
+              <a:cs typeface="Calibri"/>
+              <a:sym typeface="Calibri"/>
+            </a:endParaRPr>
+          </a:p>
+        </p:txBody>
+      </p:sp>
+      <p:sp>
+        <p:nvSpPr>
+          <p:cNvPr id="55" name="Google Shape;55;p4"/>
+          <p:cNvSpPr/>
+          <p:nvPr/>
+        </p:nvSpPr>
+        <p:spPr>
+          <a:xfrm>
+            <a:off x="5486400" y="1389888"/>
+            <a:ext cx="3291840" cy="1307592"/>
+          </a:xfrm>
+          <a:prstGeom prst="rect">
+            <a:avLst/>
+          </a:prstGeom>
+          <a:noFill/>
+          <a:ln>
+            <a:noFill/>
+          </a:ln>
+        </p:spPr>
+        <p:txBody>
+          <a:bodyPr spcFirstLastPara="1" wrap="square" lIns="0" tIns="0" rIns="0" bIns="0" anchor="ctr" anchorCtr="0">
+            <a:noAutofit/>
+          </a:bodyPr>
+          <a:lstStyle/>
+          <a:p>
+            <a:pPr marL="342900" marR="0" lvl="0" indent="-342900" algn="l" rtl="0">
+              <a:spcBef>
+                <a:spcPts val="0"/>
+              </a:spcBef>
+              <a:spcAft>
+                <a:spcPts val="0"/>
+              </a:spcAft>
+              <a:buClr>
+                <a:srgbClr val="37474F"/>
+              </a:buClr>
+              <a:buSzPts val="1000"/>
+              <a:buFont typeface="Open Sans"/>
+              <a:buChar char="•"/>
+            </a:pPr>
+            <a:r>
+              <a:rPr lang="en-US" sz="1000" b="0" i="0" u="none" strike="noStrike" cap="none">
+                <a:solidFill>
+                  <a:srgbClr val="37474F"/>
+                </a:solidFill>
+                <a:latin typeface="Open Sans"/>
+                <a:ea typeface="Open Sans"/>
+                <a:cs typeface="Open Sans"/>
+                <a:sym typeface="Open Sans"/>
+              </a:rPr>
+              <a:t>Eligible reps = cleared Line Average on every required KPI</a:t>
+            </a:r>
+            <a:endParaRPr sz="1000" b="0" i="0" u="none" strike="noStrike" cap="none">
+              <a:solidFill>
+                <a:schemeClr val="dk1"/>
+              </a:solidFill>
+              <a:latin typeface="Calibri"/>
+              <a:ea typeface="Calibri"/>
+              <a:cs typeface="Calibri"/>
+              <a:sym typeface="Calibri"/>
+            </a:endParaRPr>
+          </a:p>
+          <a:p>
+            <a:pPr marL="342900" marR="0" lvl="0" indent="-342900" algn="l" rtl="0">
+              <a:spcBef>
+                <a:spcPts val="0"/>
+              </a:spcBef>
+              <a:spcAft>
+                <a:spcPts val="0"/>
+              </a:spcAft>
+              <a:buClr>
+                <a:srgbClr val="37474F"/>
+              </a:buClr>
+              <a:buSzPts val="1000"/>
+              <a:buFont typeface="Open Sans"/>
+              <a:buChar char="•"/>
+            </a:pPr>
+            <a:r>
+              <a:rPr lang="en-US" sz="1000" b="0" i="0" u="none" strike="noStrike" cap="none">
+                <a:solidFill>
+                  <a:srgbClr val="37474F"/>
+                </a:solidFill>
+                <a:latin typeface="Open Sans"/>
+                <a:ea typeface="Open Sans"/>
+                <a:cs typeface="Open Sans"/>
+                <a:sym typeface="Open Sans"/>
+              </a:rPr>
+              <a:t>Eligible reps ranked by Total Points within their Line</a:t>
+            </a:r>
+            <a:endParaRPr sz="1000" b="0" i="0" u="none" strike="noStrike" cap="none">
+              <a:solidFill>
+                <a:schemeClr val="dk1"/>
+              </a:solidFill>
+              <a:latin typeface="Calibri"/>
+              <a:ea typeface="Calibri"/>
+              <a:cs typeface="Calibri"/>
+              <a:sym typeface="Calibri"/>
+            </a:endParaRPr>
+          </a:p>
+          <a:p>
+            <a:pPr marL="342900" marR="0" lvl="0" indent="-342900" algn="l" rtl="0">
+              <a:spcBef>
+                <a:spcPts val="0"/>
+              </a:spcBef>
+              <a:spcAft>
+                <a:spcPts val="0"/>
+              </a:spcAft>
+              <a:buClr>
+                <a:srgbClr val="37474F"/>
+              </a:buClr>
+              <a:buSzPts val="1000"/>
+              <a:buFont typeface="Open Sans"/>
+              <a:buChar char="•"/>
+            </a:pPr>
+            <a:r>
+              <a:rPr lang="en-US" sz="1000" b="0" i="0" u="none" strike="noStrike" cap="none">
+                <a:solidFill>
+                  <a:srgbClr val="37474F"/>
+                </a:solidFill>
+                <a:latin typeface="Open Sans"/>
+                <a:ea typeface="Open Sans"/>
+                <a:cs typeface="Open Sans"/>
+                <a:sym typeface="Open Sans"/>
+              </a:rPr>
+              <a:t>Top 2 ranked reps = Winner (#1) and Runner-Up (#2)</a:t>
+            </a:r>
+            <a:endParaRPr sz="1000" b="0" i="0" u="none" strike="noStrike" cap="none">
+              <a:solidFill>
+                <a:schemeClr val="dk1"/>
+              </a:solidFill>
+              <a:latin typeface="Calibri"/>
+              <a:ea typeface="Calibri"/>
+              <a:cs typeface="Calibri"/>
+              <a:sym typeface="Calibri"/>
+            </a:endParaRPr>
+          </a:p>
+          <a:p>
+            <a:pPr marL="342900" marR="0" lvl="0" indent="-342900" algn="l" rtl="0">
+              <a:spcBef>
+                <a:spcPts val="0"/>
+              </a:spcBef>
+              <a:spcAft>
+                <a:spcPts val="0"/>
+              </a:spcAft>
+              <a:buClr>
+                <a:srgbClr val="37474F"/>
+              </a:buClr>
+              <a:buSzPts val="1000"/>
+              <a:buFont typeface="Open Sans"/>
+              <a:buChar char="•"/>
+            </a:pPr>
+            <a:r>
+              <a:rPr lang="en-US" sz="1000" b="0" i="0" u="none" strike="noStrike" cap="none">
+                <a:solidFill>
+                  <a:srgbClr val="37474F"/>
+                </a:solidFill>
+                <a:latin typeface="Open Sans"/>
+                <a:ea typeface="Open Sans"/>
+                <a:cs typeface="Open Sans"/>
+                <a:sym typeface="Open Sans"/>
+              </a:rPr>
+              <a:t>Applies equally to Monthly Sprint, Quarterly &amp; Annual Marathon</a:t>
+            </a:r>
+            <a:endParaRPr sz="1000" b="0" i="0" u="none" strike="noStrike" cap="none">
+              <a:solidFill>
+                <a:schemeClr val="dk1"/>
+              </a:solidFill>
+              <a:latin typeface="Calibri"/>
+              <a:ea typeface="Calibri"/>
+              <a:cs typeface="Calibri"/>
+              <a:sym typeface="Calibri"/>
+            </a:endParaRPr>
+          </a:p>
+        </p:txBody>
+      </p:sp>
+      <p:sp>
+        <p:nvSpPr>
+          <p:cNvPr id="56" name="Google Shape;56;p4"/>
+          <p:cNvSpPr/>
+          <p:nvPr/>
+        </p:nvSpPr>
+        <p:spPr>
+          <a:xfrm>
+            <a:off x="5394960" y="2926080"/>
+            <a:ext cx="3474720" cy="1920240"/>
+          </a:xfrm>
+          <a:prstGeom prst="roundRect">
+            <a:avLst>
+              <a:gd name="adj" fmla="val 3810"/>
+            </a:avLst>
+          </a:prstGeom>
+          <a:solidFill>
+            <a:srgbClr val="FFFFFF"/>
+          </a:solidFill>
+          <a:ln w="12700" cap="flat" cmpd="sng">
+            <a:solidFill>
+              <a:srgbClr val="E0E6F0"/>
+            </a:solidFill>
+            <a:prstDash val="solid"/>
+            <a:round/>
+            <a:headEnd type="none" w="sm" len="sm"/>
+            <a:tailEnd type="none" w="sm" len="sm"/>
+          </a:ln>
+          <a:effectLst>
+            <a:outerShdw blurRad="76200" dist="25400" dir="8100000" algn="bl" rotWithShape="0">
+              <a:srgbClr val="000000">
+                <a:alpha val="7843"/>
+              </a:srgbClr>
+            </a:outerShdw>
+          </a:effectLst>
+        </p:spPr>
+        <p:txBody>
+          <a:bodyPr spcFirstLastPara="1" wrap="square" lIns="91425" tIns="91425" rIns="91425" bIns="91425" anchor="ctr" anchorCtr="0">
+            <a:noAutofit/>
+          </a:bodyPr>
+          <a:lstStyle/>
+          <a:p>
+            <a:pPr marL="0" lvl="0" indent="0" algn="l" rtl="0">
+              <a:spcBef>
+                <a:spcPts val="0"/>
+              </a:spcBef>
+              <a:spcAft>
+                <a:spcPts val="0"/>
+              </a:spcAft>
+              <a:buNone/>
+            </a:pPr>
+            <a:endParaRPr/>
+          </a:p>
+        </p:txBody>
+      </p:sp>
+      <p:sp>
+        <p:nvSpPr>
+          <p:cNvPr id="57" name="Google Shape;57;p4"/>
+          <p:cNvSpPr/>
+          <p:nvPr/>
+        </p:nvSpPr>
+        <p:spPr>
+          <a:xfrm>
+            <a:off x="5486400" y="2971800"/>
+            <a:ext cx="3291840" cy="347472"/>
+          </a:xfrm>
+          <a:prstGeom prst="rect">
+            <a:avLst/>
+          </a:prstGeom>
+          <a:noFill/>
+          <a:ln>
+            <a:noFill/>
+          </a:ln>
+        </p:spPr>
+        <p:txBody>
+          <a:bodyPr spcFirstLastPara="1" wrap="square" lIns="0" tIns="0" rIns="0" bIns="0" anchor="ctr" anchorCtr="0">
+            <a:noAutofit/>
+          </a:bodyPr>
+          <a:lstStyle/>
+          <a:p>
+            <a:pPr marL="0" marR="0" lvl="0" indent="0" algn="l" rtl="0">
+              <a:spcBef>
+                <a:spcPts val="0"/>
+              </a:spcBef>
+              <a:spcAft>
+                <a:spcPts val="0"/>
+              </a:spcAft>
+              <a:buClr>
+                <a:srgbClr val="0F2557"/>
+              </a:buClr>
+              <a:buSzPts val="1200"/>
+              <a:buFont typeface="Montserrat"/>
+              <a:buNone/>
+            </a:pPr>
+            <a:r>
+              <a:rPr lang="en-US" sz="1200" b="1" i="0" u="none" strike="noStrike" cap="none">
+                <a:solidFill>
+                  <a:srgbClr val="0F2557"/>
+                </a:solidFill>
+                <a:latin typeface="Montserrat"/>
+                <a:ea typeface="Montserrat"/>
+                <a:cs typeface="Montserrat"/>
+                <a:sym typeface="Montserrat"/>
+              </a:rPr>
+              <a:t>Key Rules</a:t>
+            </a:r>
+            <a:endParaRPr sz="1200" b="0" i="0" u="none" strike="noStrike" cap="none">
+              <a:solidFill>
+                <a:schemeClr val="dk1"/>
+              </a:solidFill>
+              <a:latin typeface="Calibri"/>
+              <a:ea typeface="Calibri"/>
+              <a:cs typeface="Calibri"/>
+              <a:sym typeface="Calibri"/>
+            </a:endParaRPr>
+          </a:p>
+        </p:txBody>
+      </p:sp>
+      <p:sp>
+        <p:nvSpPr>
+          <p:cNvPr id="58" name="Google Shape;58;p4"/>
+          <p:cNvSpPr/>
+          <p:nvPr/>
+        </p:nvSpPr>
+        <p:spPr>
+          <a:xfrm>
+            <a:off x="5486400" y="3310128"/>
+            <a:ext cx="3291840" cy="1408176"/>
+          </a:xfrm>
+          <a:prstGeom prst="rect">
+            <a:avLst/>
+          </a:prstGeom>
+          <a:noFill/>
+          <a:ln>
+            <a:noFill/>
+          </a:ln>
+        </p:spPr>
+        <p:txBody>
+          <a:bodyPr spcFirstLastPara="1" wrap="square" lIns="0" tIns="0" rIns="0" bIns="0" anchor="ctr" anchorCtr="0">
+            <a:noAutofit/>
+          </a:bodyPr>
+          <a:lstStyle/>
+          <a:p>
+            <a:pPr marL="342900" marR="0" lvl="0" indent="-342900" algn="l" rtl="0">
+              <a:spcBef>
+                <a:spcPts val="0"/>
+              </a:spcBef>
+              <a:spcAft>
+                <a:spcPts val="0"/>
+              </a:spcAft>
+              <a:buClr>
+                <a:srgbClr val="37474F"/>
+              </a:buClr>
+              <a:buSzPts val="950"/>
+              <a:buFont typeface="Open Sans"/>
+              <a:buChar char="•"/>
+            </a:pPr>
+            <a:r>
+              <a:rPr lang="en-US" sz="950" b="0" i="0" u="none" strike="noStrike" cap="none">
+                <a:solidFill>
+                  <a:srgbClr val="37474F"/>
+                </a:solidFill>
+                <a:latin typeface="Open Sans"/>
+                <a:ea typeface="Open Sans"/>
+                <a:cs typeface="Open Sans"/>
+                <a:sym typeface="Open Sans"/>
+              </a:rPr>
+              <a:t>Gate is Line AVERAGE — updated Aug 2026 (previously Line Median)</a:t>
+            </a:r>
+            <a:endParaRPr sz="950" b="0" i="0" u="none" strike="noStrike" cap="none">
+              <a:solidFill>
+                <a:schemeClr val="dk1"/>
+              </a:solidFill>
+              <a:latin typeface="Calibri"/>
+              <a:ea typeface="Calibri"/>
+              <a:cs typeface="Calibri"/>
+              <a:sym typeface="Calibri"/>
+            </a:endParaRPr>
+          </a:p>
+          <a:p>
+            <a:pPr marL="342900" marR="0" lvl="0" indent="-342900" algn="l" rtl="0">
+              <a:spcBef>
+                <a:spcPts val="0"/>
+              </a:spcBef>
+              <a:spcAft>
+                <a:spcPts val="0"/>
+              </a:spcAft>
+              <a:buClr>
+                <a:srgbClr val="37474F"/>
+              </a:buClr>
+              <a:buSzPts val="950"/>
+              <a:buFont typeface="Open Sans"/>
+              <a:buChar char="•"/>
+            </a:pPr>
+            <a:r>
+              <a:rPr lang="en-US" sz="950" b="0" i="0" u="none" strike="noStrike" cap="none">
+                <a:solidFill>
+                  <a:srgbClr val="37474F"/>
+                </a:solidFill>
+                <a:latin typeface="Open Sans"/>
+                <a:ea typeface="Open Sans"/>
+                <a:cs typeface="Open Sans"/>
+                <a:sym typeface="Open Sans"/>
+              </a:rPr>
+              <a:t>Must clear the gate on ALL required KPIs — partial clears don't qualify</a:t>
+            </a:r>
+            <a:endParaRPr sz="950" b="0" i="0" u="none" strike="noStrike" cap="none">
+              <a:solidFill>
+                <a:schemeClr val="dk1"/>
+              </a:solidFill>
+              <a:latin typeface="Calibri"/>
+              <a:ea typeface="Calibri"/>
+              <a:cs typeface="Calibri"/>
+              <a:sym typeface="Calibri"/>
+            </a:endParaRPr>
+          </a:p>
+          <a:p>
+            <a:pPr marL="342900" marR="0" lvl="0" indent="-342900" algn="l" rtl="0">
+              <a:spcBef>
+                <a:spcPts val="0"/>
+              </a:spcBef>
+              <a:spcAft>
+                <a:spcPts val="0"/>
+              </a:spcAft>
+              <a:buClr>
+                <a:srgbClr val="37474F"/>
+              </a:buClr>
+              <a:buSzPts val="950"/>
+              <a:buFont typeface="Open Sans"/>
+              <a:buChar char="•"/>
+            </a:pPr>
+            <a:r>
+              <a:rPr lang="en-US" sz="950" b="0" i="0" u="none" strike="noStrike" cap="none">
+                <a:solidFill>
+                  <a:srgbClr val="37474F"/>
+                </a:solidFill>
+                <a:latin typeface="Open Sans"/>
+                <a:ea typeface="Open Sans"/>
+                <a:cs typeface="Open Sans"/>
+                <a:sym typeface="Open Sans"/>
+              </a:rPr>
+              <a:t>CHC Sales Rep is NOT scored or gated on Right Frequency</a:t>
+            </a:r>
+            <a:endParaRPr sz="950" b="0" i="0" u="none" strike="noStrike" cap="none">
+              <a:solidFill>
+                <a:schemeClr val="dk1"/>
+              </a:solidFill>
+              <a:latin typeface="Calibri"/>
+              <a:ea typeface="Calibri"/>
+              <a:cs typeface="Calibri"/>
+              <a:sym typeface="Calibri"/>
+            </a:endParaRPr>
+          </a:p>
+          <a:p>
+            <a:pPr marL="342900" marR="0" lvl="0" indent="-342900" algn="l" rtl="0">
+              <a:spcBef>
+                <a:spcPts val="0"/>
+              </a:spcBef>
+              <a:spcAft>
+                <a:spcPts val="0"/>
+              </a:spcAft>
+              <a:buClr>
+                <a:srgbClr val="37474F"/>
+              </a:buClr>
+              <a:buSzPts val="950"/>
+              <a:buFont typeface="Open Sans"/>
+              <a:buChar char="•"/>
+            </a:pPr>
+            <a:r>
+              <a:rPr lang="en-US" sz="950" b="0" i="0" u="none" strike="noStrike" cap="none">
+                <a:solidFill>
+                  <a:srgbClr val="37474F"/>
+                </a:solidFill>
+                <a:latin typeface="Open Sans"/>
+                <a:ea typeface="Open Sans"/>
+                <a:cs typeface="Open Sans"/>
+                <a:sym typeface="Open Sans"/>
+              </a:rPr>
+              <a:t>A #2 rep tied in points with #1 is promoted to Co-Winner</a:t>
+            </a:r>
+            <a:endParaRPr sz="950" b="0" i="0" u="none" strike="noStrike" cap="none">
+              <a:solidFill>
+                <a:schemeClr val="dk1"/>
+              </a:solidFill>
+              <a:latin typeface="Calibri"/>
+              <a:ea typeface="Calibri"/>
+              <a:cs typeface="Calibri"/>
+              <a:sym typeface="Calibri"/>
+            </a:endParaRPr>
+          </a:p>
+          <a:p>
+            <a:pPr marL="342900" marR="0" lvl="0" indent="-342900" algn="l" rtl="0">
+              <a:spcBef>
+                <a:spcPts val="0"/>
+              </a:spcBef>
+              <a:spcAft>
+                <a:spcPts val="0"/>
+              </a:spcAft>
+              <a:buClr>
+                <a:srgbClr val="37474F"/>
+              </a:buClr>
+              <a:buSzPts val="950"/>
+              <a:buFont typeface="Open Sans"/>
+              <a:buChar char="•"/>
+            </a:pPr>
+            <a:r>
+              <a:rPr lang="en-US" sz="950" b="0" i="0" u="none" strike="noStrike" cap="none">
+                <a:solidFill>
+                  <a:srgbClr val="37474F"/>
+                </a:solidFill>
+                <a:latin typeface="Open Sans"/>
+                <a:ea typeface="Open Sans"/>
+                <a:cs typeface="Open Sans"/>
+                <a:sym typeface="Open Sans"/>
+              </a:rPr>
+              <a:t>No eligible reps in a Line = no Monthly Sprint winner that cycle</a:t>
+            </a:r>
+            <a:endParaRPr sz="950" b="0" i="0" u="none" strike="noStrike" cap="none">
+              <a:solidFill>
+                <a:schemeClr val="dk1"/>
+              </a:solidFill>
+              <a:latin typeface="Calibri"/>
+              <a:ea typeface="Calibri"/>
+              <a:cs typeface="Calibri"/>
+              <a:sym typeface="Calibri"/>
+            </a:endParaRPr>
+          </a:p>
+        </p:txBody>
+      </p:sp>
+    </p:spTree>
+    <p:extLst>
+      <p:ext uri="{BB962C8B-B14F-4D97-AF65-F5344CB8AC3E}">
+        <p14:creationId xmlns:p14="http://schemas.microsoft.com/office/powerpoint/2010/main" val="920220915"/>
+      </p:ext>
+    </p:extLst>
+  </p:cSld>
+  <p:clrMapOvr>
+    <a:masterClrMapping/>
+  </p:clrMapOvr>
+</p:sld>
+</file>
+
+<file path=ppt/slides/slide11.xml><?xml version="1.0" encoding="utf-8"?>
+<p:sld xmlns:a="http://schemas.openxmlformats.org/drawingml/2006/main" xmlns:r="http://schemas.openxmlformats.org/officeDocument/2006/relationships" xmlns:p="http://schemas.openxmlformats.org/presentationml/2006/main">
+  <p:cSld>
+    <p:bg>
+      <p:bgPr>
+        <a:solidFill>
           <a:srgbClr val="0F2557"/>
         </a:solidFill>
         <a:effectLst/>
@@ -6726,7 +8586,7 @@
 </p:sld>
 </file>
 
-<file path=ppt/slides/slide11.xml><?xml version="1.0" encoding="utf-8"?>
+<file path=ppt/slides/slide12.xml><?xml version="1.0" encoding="utf-8"?>
 <p:sld xmlns:a="http://schemas.openxmlformats.org/drawingml/2006/main" xmlns:r="http://schemas.openxmlformats.org/officeDocument/2006/relationships" xmlns:p="http://schemas.openxmlformats.org/presentationml/2006/main">
   <p:cSld>
     <p:bg>
@@ -8815,6 +10675,69 @@
           </a:p>
         </p:txBody>
       </p:sp>
+      <p:sp>
+        <p:nvSpPr>
+          <p:cNvPr id="165" name="Google Shape;165;p6"/>
+          <p:cNvSpPr/>
+          <p:nvPr/>
+        </p:nvSpPr>
+        <p:spPr>
+          <a:xfrm>
+            <a:off x="365760" y="4790000"/>
+            <a:ext cx="8412480" cy="330000"/>
+          </a:xfrm>
+          <a:prstGeom prst="rect">
+            <a:avLst/>
+          </a:prstGeom>
+          <a:noFill/>
+          <a:ln>
+            <a:noFill/>
+          </a:ln>
+        </p:spPr>
+        <p:txBody>
+          <a:bodyPr spcFirstLastPara="1" wrap="square" lIns="0" tIns="0" rIns="0" bIns="0" anchor="ctr" anchorCtr="0">
+            <a:noAutofit/>
+          </a:bodyPr>
+          <a:lstStyle/>
+          <a:p>
+            <a:pPr marL="0" marR="0" lvl="0" indent="0" algn="l" rtl="0">
+              <a:spcBef>
+                <a:spcPts val="0"/>
+              </a:spcBef>
+              <a:spcAft>
+                <a:spcPts val="0"/>
+              </a:spcAft>
+              <a:buClr>
+                <a:srgbClr val="1E50C9"/>
+              </a:buClr>
+              <a:buSzPts val="950"/>
+              <a:buFont typeface="Open Sans"/>
+              <a:buNone/>
+            </a:pPr>
+            <a:r>
+              <a:rPr lang="en-US" sz="950" b="0" i="1" u="none" strike="noStrike" cap="none" dirty="0">
+                <a:solidFill>
+                  <a:srgbClr val="1E50C9"/>
+                </a:solidFill>
+                <a:latin typeface="Open Sans"/>
+                <a:ea typeface="Open Sans"/>
+                <a:cs typeface="Open Sans"/>
+                <a:sym typeface="Open Sans"/>
+              </a:rPr>
+              <a:t>Winners = eligible reps only (cleared Line Average on every required KPI). See "Winner Pool — How Winners Are Determined" for full eligibility, ranking &amp; tie rules.</a:t>
+            </a:r>
+            <a:endParaRPr sz="950" b="0" i="0" u="none" strike="noStrike" cap="none" dirty="0">
+              <a:solidFill>
+                <a:schemeClr val="dk1"/>
+              </a:solidFill>
+              <a:latin typeface="Calibri"/>
+              <a:ea typeface="Calibri"/>
+              <a:cs typeface="Calibri"/>
+              <a:sym typeface="Calibri"/>
+            </a:endParaRPr>
+          </a:p>
+        </p:txBody>
+      </p:sp>
     </p:spTree>
     <p:extLst>
       <p:ext uri="{BB962C8B-B14F-4D97-AF65-F5344CB8AC3E}">
@@ -8828,7 +10751,7 @@
 </p:sld>
 </file>
 
-<file path=ppt/slides/slide12.xml><?xml version="1.0" encoding="utf-8"?>
+<file path=ppt/slides/slide13.xml><?xml version="1.0" encoding="utf-8"?>
 <p:sld xmlns:a="http://schemas.openxmlformats.org/drawingml/2006/main" xmlns:r="http://schemas.openxmlformats.org/officeDocument/2006/relationships" xmlns:p="http://schemas.openxmlformats.org/presentationml/2006/main">
   <p:cSld>
     <p:bg>
@@ -11006,7 +12929,7 @@
 </p:sld>
 </file>
 
-<file path=ppt/slides/slide13.xml><?xml version="1.0" encoding="utf-8"?>
+<file path=ppt/slides/slide14.xml><?xml version="1.0" encoding="utf-8"?>
 <p:sld xmlns:a="http://schemas.openxmlformats.org/drawingml/2006/main" xmlns:r="http://schemas.openxmlformats.org/officeDocument/2006/relationships" xmlns:p="http://schemas.openxmlformats.org/presentationml/2006/main">
   <p:cSld>
     <p:bg>
@@ -13070,7 +14993,7 @@
 </p:sld>
 </file>
 
-<file path=ppt/slides/slide14.xml><?xml version="1.0" encoding="utf-8"?>
+<file path=ppt/slides/slide15.xml><?xml version="1.0" encoding="utf-8"?>
 <p:sld xmlns:a="http://schemas.openxmlformats.org/drawingml/2006/main" xmlns:r="http://schemas.openxmlformats.org/officeDocument/2006/relationships" xmlns:p="http://schemas.openxmlformats.org/presentationml/2006/main">
   <p:cSld>
     <p:bg>
@@ -15134,7 +17057,7 @@
 </p:sld>
 </file>
 
-<file path=ppt/slides/slide15.xml><?xml version="1.0" encoding="utf-8"?>
+<file path=ppt/slides/slide16.xml><?xml version="1.0" encoding="utf-8"?>
 <p:sld xmlns:a="http://schemas.openxmlformats.org/drawingml/2006/main" xmlns:r="http://schemas.openxmlformats.org/officeDocument/2006/relationships" xmlns:p="http://schemas.openxmlformats.org/presentationml/2006/main">
   <p:cSld>
     <p:bg>
@@ -16936,7 +18859,7 @@
 </p:sld>
 </file>
 
-<file path=ppt/slides/slide16.xml><?xml version="1.0" encoding="utf-8"?>
+<file path=ppt/slides/slide17.xml><?xml version="1.0" encoding="utf-8"?>
 <p:sld xmlns:a="http://schemas.openxmlformats.org/drawingml/2006/main" xmlns:r="http://schemas.openxmlformats.org/officeDocument/2006/relationships" xmlns:p="http://schemas.openxmlformats.org/presentationml/2006/main">
   <p:cSld>
     <p:bg>
@@ -17270,7 +19193,7 @@
 </p:sld>
 </file>
 
-<file path=ppt/slides/slide17.xml><?xml version="1.0" encoding="utf-8"?>
+<file path=ppt/slides/slide18.xml><?xml version="1.0" encoding="utf-8"?>
 <p:sld xmlns:a="http://schemas.openxmlformats.org/drawingml/2006/main" xmlns:r="http://schemas.openxmlformats.org/officeDocument/2006/relationships" xmlns:p="http://schemas.openxmlformats.org/presentationml/2006/main">
   <p:cSld>
     <p:bg>
@@ -20595,7 +22518,7 @@
 </p:sld>
 </file>
 
-<file path=ppt/slides/slide18.xml><?xml version="1.0" encoding="utf-8"?>
+<file path=ppt/slides/slide19.xml><?xml version="1.0" encoding="utf-8"?>
 <p:sld xmlns:a="http://schemas.openxmlformats.org/drawingml/2006/main" xmlns:r="http://schemas.openxmlformats.org/officeDocument/2006/relationships" xmlns:p="http://schemas.openxmlformats.org/presentationml/2006/main">
   <p:cSld>
     <p:bg>
@@ -23824,340 +25747,6 @@
     <p:extLst>
       <p:ext uri="{BB962C8B-B14F-4D97-AF65-F5344CB8AC3E}">
         <p14:creationId xmlns:p14="http://schemas.microsoft.com/office/powerpoint/2010/main" val="3366967112"/>
-      </p:ext>
-    </p:extLst>
-  </p:cSld>
-  <p:clrMapOvr>
-    <a:masterClrMapping/>
-  </p:clrMapOvr>
-</p:sld>
-</file>
-
-<file path=ppt/slides/slide19.xml><?xml version="1.0" encoding="utf-8"?>
-<p:sld xmlns:a="http://schemas.openxmlformats.org/drawingml/2006/main" xmlns:r="http://schemas.openxmlformats.org/officeDocument/2006/relationships" xmlns:p="http://schemas.openxmlformats.org/presentationml/2006/main">
-  <p:cSld>
-    <p:bg>
-      <p:bgPr>
-        <a:solidFill>
-          <a:srgbClr val="0F2557"/>
-        </a:solidFill>
-        <a:effectLst/>
-      </p:bgPr>
-    </p:bg>
-    <p:spTree>
-      <p:nvGrpSpPr>
-        <p:cNvPr id="1" name="Shape 999"/>
-        <p:cNvGrpSpPr/>
-        <p:nvPr/>
-      </p:nvGrpSpPr>
-      <p:grpSpPr>
-        <a:xfrm>
-          <a:off x="0" y="0"/>
-          <a:ext cx="0" cy="0"/>
-          <a:chOff x="0" y="0"/>
-          <a:chExt cx="0" cy="0"/>
-        </a:xfrm>
-      </p:grpSpPr>
-      <p:sp>
-        <p:nvSpPr>
-          <p:cNvPr id="1000" name="Google Shape;1000;p23"/>
-          <p:cNvSpPr/>
-          <p:nvPr/>
-        </p:nvSpPr>
-        <p:spPr>
-          <a:xfrm>
-            <a:off x="0" y="0"/>
-            <a:ext cx="457200" cy="5143500"/>
-          </a:xfrm>
-          <a:prstGeom prst="rect">
-            <a:avLst/>
-          </a:prstGeom>
-          <a:solidFill>
-            <a:srgbClr val="FAAD14"/>
-          </a:solidFill>
-          <a:ln w="12700" cap="flat" cmpd="sng">
-            <a:solidFill>
-              <a:srgbClr val="FAAD14"/>
-            </a:solidFill>
-            <a:prstDash val="solid"/>
-            <a:round/>
-            <a:headEnd type="none" w="sm" len="sm"/>
-            <a:tailEnd type="none" w="sm" len="sm"/>
-          </a:ln>
-        </p:spPr>
-        <p:txBody>
-          <a:bodyPr spcFirstLastPara="1" wrap="square" lIns="91425" tIns="91425" rIns="91425" bIns="91425" anchor="ctr" anchorCtr="0">
-            <a:noAutofit/>
-          </a:bodyPr>
-          <a:lstStyle/>
-          <a:p>
-            <a:pPr marL="0" lvl="0" indent="0" algn="l" rtl="0">
-              <a:spcBef>
-                <a:spcPts val="0"/>
-              </a:spcBef>
-              <a:spcAft>
-                <a:spcPts val="0"/>
-              </a:spcAft>
-              <a:buNone/>
-            </a:pPr>
-            <a:endParaRPr/>
-          </a:p>
-        </p:txBody>
-      </p:sp>
-      <p:sp>
-        <p:nvSpPr>
-          <p:cNvPr id="1003" name="Google Shape;1003;p23"/>
-          <p:cNvSpPr/>
-          <p:nvPr/>
-        </p:nvSpPr>
-        <p:spPr>
-          <a:xfrm>
-            <a:off x="731520" y="1417320"/>
-            <a:ext cx="1005840" cy="1005840"/>
-          </a:xfrm>
-          <a:prstGeom prst="ellipse">
-            <a:avLst/>
-          </a:prstGeom>
-          <a:solidFill>
-            <a:srgbClr val="FAAD14">
-              <a:alpha val="80000"/>
-            </a:srgbClr>
-          </a:solidFill>
-          <a:ln w="25400" cap="flat" cmpd="sng">
-            <a:solidFill>
-              <a:srgbClr val="FAAD14"/>
-            </a:solidFill>
-            <a:prstDash val="solid"/>
-            <a:round/>
-            <a:headEnd type="none" w="sm" len="sm"/>
-            <a:tailEnd type="none" w="sm" len="sm"/>
-          </a:ln>
-        </p:spPr>
-        <p:txBody>
-          <a:bodyPr spcFirstLastPara="1" wrap="square" lIns="91425" tIns="91425" rIns="91425" bIns="91425" anchor="ctr" anchorCtr="0">
-            <a:noAutofit/>
-          </a:bodyPr>
-          <a:lstStyle/>
-          <a:p>
-            <a:pPr marL="0" lvl="0" indent="0" algn="l" rtl="0">
-              <a:spcBef>
-                <a:spcPts val="0"/>
-              </a:spcBef>
-              <a:spcAft>
-                <a:spcPts val="0"/>
-              </a:spcAft>
-              <a:buNone/>
-            </a:pPr>
-            <a:endParaRPr/>
-          </a:p>
-        </p:txBody>
-      </p:sp>
-      <p:sp>
-        <p:nvSpPr>
-          <p:cNvPr id="1004" name="Google Shape;1004;p23"/>
-          <p:cNvSpPr/>
-          <p:nvPr/>
-        </p:nvSpPr>
-        <p:spPr>
-          <a:xfrm>
-            <a:off x="640080" y="2286000"/>
-            <a:ext cx="7315200" cy="1005840"/>
-          </a:xfrm>
-          <a:prstGeom prst="rect">
-            <a:avLst/>
-          </a:prstGeom>
-          <a:noFill/>
-          <a:ln>
-            <a:noFill/>
-          </a:ln>
-        </p:spPr>
-        <p:txBody>
-          <a:bodyPr spcFirstLastPara="1" wrap="square" lIns="0" tIns="0" rIns="0" bIns="0" anchor="ctr" anchorCtr="0">
-            <a:noAutofit/>
-          </a:bodyPr>
-          <a:lstStyle/>
-          <a:p>
-            <a:pPr marL="0" marR="0" lvl="0" indent="0" algn="l" rtl="0">
-              <a:spcBef>
-                <a:spcPts val="0"/>
-              </a:spcBef>
-              <a:spcAft>
-                <a:spcPts val="0"/>
-              </a:spcAft>
-              <a:buClr>
-                <a:srgbClr val="FFFFFF"/>
-              </a:buClr>
-              <a:buSzPts val="3800"/>
-              <a:buFont typeface="Montserrat"/>
-              <a:buNone/>
-            </a:pPr>
-            <a:r>
-              <a:rPr lang="en-US" sz="3800" b="1" i="0" u="none" strike="noStrike" cap="none">
-                <a:solidFill>
-                  <a:srgbClr val="FFFFFF"/>
-                </a:solidFill>
-                <a:latin typeface="Montserrat"/>
-                <a:ea typeface="Montserrat"/>
-                <a:cs typeface="Montserrat"/>
-                <a:sym typeface="Montserrat"/>
-              </a:rPr>
-              <a:t>Install on Your Device</a:t>
-            </a:r>
-            <a:endParaRPr sz="3800" b="0" i="0" u="none" strike="noStrike" cap="none">
-              <a:solidFill>
-                <a:schemeClr val="dk1"/>
-              </a:solidFill>
-              <a:latin typeface="Calibri"/>
-              <a:ea typeface="Calibri"/>
-              <a:cs typeface="Calibri"/>
-              <a:sym typeface="Calibri"/>
-            </a:endParaRPr>
-          </a:p>
-        </p:txBody>
-      </p:sp>
-      <p:sp>
-        <p:nvSpPr>
-          <p:cNvPr id="1005" name="Google Shape;1005;p23"/>
-          <p:cNvSpPr/>
-          <p:nvPr/>
-        </p:nvSpPr>
-        <p:spPr>
-          <a:xfrm>
-            <a:off x="640080" y="3246120"/>
-            <a:ext cx="7315200" cy="502920"/>
-          </a:xfrm>
-          <a:prstGeom prst="rect">
-            <a:avLst/>
-          </a:prstGeom>
-          <a:noFill/>
-          <a:ln>
-            <a:noFill/>
-          </a:ln>
-        </p:spPr>
-        <p:txBody>
-          <a:bodyPr spcFirstLastPara="1" wrap="square" lIns="0" tIns="0" rIns="0" bIns="0" anchor="ctr" anchorCtr="0">
-            <a:noAutofit/>
-          </a:bodyPr>
-          <a:lstStyle/>
-          <a:p>
-            <a:pPr marL="0" marR="0" lvl="0" indent="0" algn="l" rtl="0">
-              <a:spcBef>
-                <a:spcPts val="0"/>
-              </a:spcBef>
-              <a:spcAft>
-                <a:spcPts val="0"/>
-              </a:spcAft>
-              <a:buClr>
-                <a:srgbClr val="FFC53D"/>
-              </a:buClr>
-              <a:buSzPts val="1600"/>
-              <a:buFont typeface="Open Sans"/>
-              <a:buNone/>
-            </a:pPr>
-            <a:r>
-              <a:rPr lang="en-US" sz="1600" b="0" i="0" u="none" strike="noStrike" cap="none">
-                <a:solidFill>
-                  <a:srgbClr val="FFC53D"/>
-                </a:solidFill>
-                <a:latin typeface="Open Sans"/>
-                <a:ea typeface="Open Sans"/>
-                <a:cs typeface="Open Sans"/>
-                <a:sym typeface="Open Sans"/>
-              </a:rPr>
-              <a:t>Save Zeta Sprint to your phone or desktop for quick access</a:t>
-            </a:r>
-            <a:endParaRPr sz="1600" b="0" i="0" u="none" strike="noStrike" cap="none">
-              <a:solidFill>
-                <a:schemeClr val="dk1"/>
-              </a:solidFill>
-              <a:latin typeface="Calibri"/>
-              <a:ea typeface="Calibri"/>
-              <a:cs typeface="Calibri"/>
-              <a:sym typeface="Calibri"/>
-            </a:endParaRPr>
-          </a:p>
-        </p:txBody>
-      </p:sp>
-      <p:sp>
-        <p:nvSpPr>
-          <p:cNvPr id="1006" name="Google Shape;1006;p23"/>
-          <p:cNvSpPr/>
-          <p:nvPr/>
-        </p:nvSpPr>
-        <p:spPr>
-          <a:xfrm>
-            <a:off x="640080" y="4754880"/>
-            <a:ext cx="2286000" cy="54864"/>
-          </a:xfrm>
-          <a:prstGeom prst="rect">
-            <a:avLst/>
-          </a:prstGeom>
-          <a:solidFill>
-            <a:srgbClr val="FAAD14"/>
-          </a:solidFill>
-          <a:ln w="12700" cap="flat" cmpd="sng">
-            <a:solidFill>
-              <a:srgbClr val="FAAD14"/>
-            </a:solidFill>
-            <a:prstDash val="solid"/>
-            <a:round/>
-            <a:headEnd type="none" w="sm" len="sm"/>
-            <a:tailEnd type="none" w="sm" len="sm"/>
-          </a:ln>
-        </p:spPr>
-        <p:txBody>
-          <a:bodyPr spcFirstLastPara="1" wrap="square" lIns="91425" tIns="91425" rIns="91425" bIns="91425" anchor="ctr" anchorCtr="0">
-            <a:noAutofit/>
-          </a:bodyPr>
-          <a:lstStyle/>
-          <a:p>
-            <a:pPr marL="0" lvl="0" indent="0" algn="l" rtl="0">
-              <a:spcBef>
-                <a:spcPts val="0"/>
-              </a:spcBef>
-              <a:spcAft>
-                <a:spcPts val="0"/>
-              </a:spcAft>
-              <a:buNone/>
-            </a:pPr>
-            <a:endParaRPr/>
-          </a:p>
-        </p:txBody>
-      </p:sp>
-      <p:pic>
-        <p:nvPicPr>
-          <p:cNvPr id="2" name="Picture 1">
-            <a:extLst>
-              <a:ext uri="{FF2B5EF4-FFF2-40B4-BE49-F238E27FC236}">
-                <a16:creationId xmlns:a16="http://schemas.microsoft.com/office/drawing/2014/main" id="{3C8424DF-337F-A18C-CF3D-67D1735B7502}"/>
-              </a:ext>
-            </a:extLst>
-          </p:cNvPr>
-          <p:cNvPicPr>
-            <a:picLocks noChangeAspect="1"/>
-          </p:cNvPicPr>
-          <p:nvPr/>
-        </p:nvPicPr>
-        <p:blipFill>
-          <a:blip r:embed="rId3"/>
-          <a:stretch>
-            <a:fillRect/>
-          </a:stretch>
-        </p:blipFill>
-        <p:spPr>
-          <a:xfrm>
-            <a:off x="6183119" y="466863"/>
-            <a:ext cx="2960881" cy="3912593"/>
-          </a:xfrm>
-          <a:prstGeom prst="rect">
-            <a:avLst/>
-          </a:prstGeom>
-        </p:spPr>
-      </p:pic>
-    </p:spTree>
-    <p:extLst>
-      <p:ext uri="{BB962C8B-B14F-4D97-AF65-F5344CB8AC3E}">
-        <p14:creationId xmlns:p14="http://schemas.microsoft.com/office/powerpoint/2010/main" val="1321706746"/>
       </p:ext>
     </p:extLst>
   </p:cSld>
@@ -26032,6 +27621,340 @@
     <p:bg>
       <p:bgPr>
         <a:solidFill>
+          <a:srgbClr val="0F2557"/>
+        </a:solidFill>
+        <a:effectLst/>
+      </p:bgPr>
+    </p:bg>
+    <p:spTree>
+      <p:nvGrpSpPr>
+        <p:cNvPr id="1" name="Shape 999"/>
+        <p:cNvGrpSpPr/>
+        <p:nvPr/>
+      </p:nvGrpSpPr>
+      <p:grpSpPr>
+        <a:xfrm>
+          <a:off x="0" y="0"/>
+          <a:ext cx="0" cy="0"/>
+          <a:chOff x="0" y="0"/>
+          <a:chExt cx="0" cy="0"/>
+        </a:xfrm>
+      </p:grpSpPr>
+      <p:sp>
+        <p:nvSpPr>
+          <p:cNvPr id="1000" name="Google Shape;1000;p23"/>
+          <p:cNvSpPr/>
+          <p:nvPr/>
+        </p:nvSpPr>
+        <p:spPr>
+          <a:xfrm>
+            <a:off x="0" y="0"/>
+            <a:ext cx="457200" cy="5143500"/>
+          </a:xfrm>
+          <a:prstGeom prst="rect">
+            <a:avLst/>
+          </a:prstGeom>
+          <a:solidFill>
+            <a:srgbClr val="FAAD14"/>
+          </a:solidFill>
+          <a:ln w="12700" cap="flat" cmpd="sng">
+            <a:solidFill>
+              <a:srgbClr val="FAAD14"/>
+            </a:solidFill>
+            <a:prstDash val="solid"/>
+            <a:round/>
+            <a:headEnd type="none" w="sm" len="sm"/>
+            <a:tailEnd type="none" w="sm" len="sm"/>
+          </a:ln>
+        </p:spPr>
+        <p:txBody>
+          <a:bodyPr spcFirstLastPara="1" wrap="square" lIns="91425" tIns="91425" rIns="91425" bIns="91425" anchor="ctr" anchorCtr="0">
+            <a:noAutofit/>
+          </a:bodyPr>
+          <a:lstStyle/>
+          <a:p>
+            <a:pPr marL="0" lvl="0" indent="0" algn="l" rtl="0">
+              <a:spcBef>
+                <a:spcPts val="0"/>
+              </a:spcBef>
+              <a:spcAft>
+                <a:spcPts val="0"/>
+              </a:spcAft>
+              <a:buNone/>
+            </a:pPr>
+            <a:endParaRPr/>
+          </a:p>
+        </p:txBody>
+      </p:sp>
+      <p:sp>
+        <p:nvSpPr>
+          <p:cNvPr id="1003" name="Google Shape;1003;p23"/>
+          <p:cNvSpPr/>
+          <p:nvPr/>
+        </p:nvSpPr>
+        <p:spPr>
+          <a:xfrm>
+            <a:off x="731520" y="1417320"/>
+            <a:ext cx="1005840" cy="1005840"/>
+          </a:xfrm>
+          <a:prstGeom prst="ellipse">
+            <a:avLst/>
+          </a:prstGeom>
+          <a:solidFill>
+            <a:srgbClr val="FAAD14">
+              <a:alpha val="80000"/>
+            </a:srgbClr>
+          </a:solidFill>
+          <a:ln w="25400" cap="flat" cmpd="sng">
+            <a:solidFill>
+              <a:srgbClr val="FAAD14"/>
+            </a:solidFill>
+            <a:prstDash val="solid"/>
+            <a:round/>
+            <a:headEnd type="none" w="sm" len="sm"/>
+            <a:tailEnd type="none" w="sm" len="sm"/>
+          </a:ln>
+        </p:spPr>
+        <p:txBody>
+          <a:bodyPr spcFirstLastPara="1" wrap="square" lIns="91425" tIns="91425" rIns="91425" bIns="91425" anchor="ctr" anchorCtr="0">
+            <a:noAutofit/>
+          </a:bodyPr>
+          <a:lstStyle/>
+          <a:p>
+            <a:pPr marL="0" lvl="0" indent="0" algn="l" rtl="0">
+              <a:spcBef>
+                <a:spcPts val="0"/>
+              </a:spcBef>
+              <a:spcAft>
+                <a:spcPts val="0"/>
+              </a:spcAft>
+              <a:buNone/>
+            </a:pPr>
+            <a:endParaRPr/>
+          </a:p>
+        </p:txBody>
+      </p:sp>
+      <p:sp>
+        <p:nvSpPr>
+          <p:cNvPr id="1004" name="Google Shape;1004;p23"/>
+          <p:cNvSpPr/>
+          <p:nvPr/>
+        </p:nvSpPr>
+        <p:spPr>
+          <a:xfrm>
+            <a:off x="640080" y="2286000"/>
+            <a:ext cx="7315200" cy="1005840"/>
+          </a:xfrm>
+          <a:prstGeom prst="rect">
+            <a:avLst/>
+          </a:prstGeom>
+          <a:noFill/>
+          <a:ln>
+            <a:noFill/>
+          </a:ln>
+        </p:spPr>
+        <p:txBody>
+          <a:bodyPr spcFirstLastPara="1" wrap="square" lIns="0" tIns="0" rIns="0" bIns="0" anchor="ctr" anchorCtr="0">
+            <a:noAutofit/>
+          </a:bodyPr>
+          <a:lstStyle/>
+          <a:p>
+            <a:pPr marL="0" marR="0" lvl="0" indent="0" algn="l" rtl="0">
+              <a:spcBef>
+                <a:spcPts val="0"/>
+              </a:spcBef>
+              <a:spcAft>
+                <a:spcPts val="0"/>
+              </a:spcAft>
+              <a:buClr>
+                <a:srgbClr val="FFFFFF"/>
+              </a:buClr>
+              <a:buSzPts val="3800"/>
+              <a:buFont typeface="Montserrat"/>
+              <a:buNone/>
+            </a:pPr>
+            <a:r>
+              <a:rPr lang="en-US" sz="3800" b="1" i="0" u="none" strike="noStrike" cap="none">
+                <a:solidFill>
+                  <a:srgbClr val="FFFFFF"/>
+                </a:solidFill>
+                <a:latin typeface="Montserrat"/>
+                <a:ea typeface="Montserrat"/>
+                <a:cs typeface="Montserrat"/>
+                <a:sym typeface="Montserrat"/>
+              </a:rPr>
+              <a:t>Install on Your Device</a:t>
+            </a:r>
+            <a:endParaRPr sz="3800" b="0" i="0" u="none" strike="noStrike" cap="none">
+              <a:solidFill>
+                <a:schemeClr val="dk1"/>
+              </a:solidFill>
+              <a:latin typeface="Calibri"/>
+              <a:ea typeface="Calibri"/>
+              <a:cs typeface="Calibri"/>
+              <a:sym typeface="Calibri"/>
+            </a:endParaRPr>
+          </a:p>
+        </p:txBody>
+      </p:sp>
+      <p:sp>
+        <p:nvSpPr>
+          <p:cNvPr id="1005" name="Google Shape;1005;p23"/>
+          <p:cNvSpPr/>
+          <p:nvPr/>
+        </p:nvSpPr>
+        <p:spPr>
+          <a:xfrm>
+            <a:off x="640080" y="3246120"/>
+            <a:ext cx="7315200" cy="502920"/>
+          </a:xfrm>
+          <a:prstGeom prst="rect">
+            <a:avLst/>
+          </a:prstGeom>
+          <a:noFill/>
+          <a:ln>
+            <a:noFill/>
+          </a:ln>
+        </p:spPr>
+        <p:txBody>
+          <a:bodyPr spcFirstLastPara="1" wrap="square" lIns="0" tIns="0" rIns="0" bIns="0" anchor="ctr" anchorCtr="0">
+            <a:noAutofit/>
+          </a:bodyPr>
+          <a:lstStyle/>
+          <a:p>
+            <a:pPr marL="0" marR="0" lvl="0" indent="0" algn="l" rtl="0">
+              <a:spcBef>
+                <a:spcPts val="0"/>
+              </a:spcBef>
+              <a:spcAft>
+                <a:spcPts val="0"/>
+              </a:spcAft>
+              <a:buClr>
+                <a:srgbClr val="FFC53D"/>
+              </a:buClr>
+              <a:buSzPts val="1600"/>
+              <a:buFont typeface="Open Sans"/>
+              <a:buNone/>
+            </a:pPr>
+            <a:r>
+              <a:rPr lang="en-US" sz="1600" b="0" i="0" u="none" strike="noStrike" cap="none">
+                <a:solidFill>
+                  <a:srgbClr val="FFC53D"/>
+                </a:solidFill>
+                <a:latin typeface="Open Sans"/>
+                <a:ea typeface="Open Sans"/>
+                <a:cs typeface="Open Sans"/>
+                <a:sym typeface="Open Sans"/>
+              </a:rPr>
+              <a:t>Save Zeta Sprint to your phone or desktop for quick access</a:t>
+            </a:r>
+            <a:endParaRPr sz="1600" b="0" i="0" u="none" strike="noStrike" cap="none">
+              <a:solidFill>
+                <a:schemeClr val="dk1"/>
+              </a:solidFill>
+              <a:latin typeface="Calibri"/>
+              <a:ea typeface="Calibri"/>
+              <a:cs typeface="Calibri"/>
+              <a:sym typeface="Calibri"/>
+            </a:endParaRPr>
+          </a:p>
+        </p:txBody>
+      </p:sp>
+      <p:sp>
+        <p:nvSpPr>
+          <p:cNvPr id="1006" name="Google Shape;1006;p23"/>
+          <p:cNvSpPr/>
+          <p:nvPr/>
+        </p:nvSpPr>
+        <p:spPr>
+          <a:xfrm>
+            <a:off x="640080" y="4754880"/>
+            <a:ext cx="2286000" cy="54864"/>
+          </a:xfrm>
+          <a:prstGeom prst="rect">
+            <a:avLst/>
+          </a:prstGeom>
+          <a:solidFill>
+            <a:srgbClr val="FAAD14"/>
+          </a:solidFill>
+          <a:ln w="12700" cap="flat" cmpd="sng">
+            <a:solidFill>
+              <a:srgbClr val="FAAD14"/>
+            </a:solidFill>
+            <a:prstDash val="solid"/>
+            <a:round/>
+            <a:headEnd type="none" w="sm" len="sm"/>
+            <a:tailEnd type="none" w="sm" len="sm"/>
+          </a:ln>
+        </p:spPr>
+        <p:txBody>
+          <a:bodyPr spcFirstLastPara="1" wrap="square" lIns="91425" tIns="91425" rIns="91425" bIns="91425" anchor="ctr" anchorCtr="0">
+            <a:noAutofit/>
+          </a:bodyPr>
+          <a:lstStyle/>
+          <a:p>
+            <a:pPr marL="0" lvl="0" indent="0" algn="l" rtl="0">
+              <a:spcBef>
+                <a:spcPts val="0"/>
+              </a:spcBef>
+              <a:spcAft>
+                <a:spcPts val="0"/>
+              </a:spcAft>
+              <a:buNone/>
+            </a:pPr>
+            <a:endParaRPr/>
+          </a:p>
+        </p:txBody>
+      </p:sp>
+      <p:pic>
+        <p:nvPicPr>
+          <p:cNvPr id="2" name="Picture 1">
+            <a:extLst>
+              <a:ext uri="{FF2B5EF4-FFF2-40B4-BE49-F238E27FC236}">
+                <a16:creationId xmlns:a16="http://schemas.microsoft.com/office/drawing/2014/main" id="{3C8424DF-337F-A18C-CF3D-67D1735B7502}"/>
+              </a:ext>
+            </a:extLst>
+          </p:cNvPr>
+          <p:cNvPicPr>
+            <a:picLocks noChangeAspect="1"/>
+          </p:cNvPicPr>
+          <p:nvPr/>
+        </p:nvPicPr>
+        <p:blipFill>
+          <a:blip r:embed="rId3"/>
+          <a:stretch>
+            <a:fillRect/>
+          </a:stretch>
+        </p:blipFill>
+        <p:spPr>
+          <a:xfrm>
+            <a:off x="6183119" y="466863"/>
+            <a:ext cx="2960881" cy="3912593"/>
+          </a:xfrm>
+          <a:prstGeom prst="rect">
+            <a:avLst/>
+          </a:prstGeom>
+        </p:spPr>
+      </p:pic>
+    </p:spTree>
+    <p:extLst>
+      <p:ext uri="{BB962C8B-B14F-4D97-AF65-F5344CB8AC3E}">
+        <p14:creationId xmlns:p14="http://schemas.microsoft.com/office/powerpoint/2010/main" val="1321706746"/>
+      </p:ext>
+    </p:extLst>
+  </p:cSld>
+  <p:clrMapOvr>
+    <a:masterClrMapping/>
+  </p:clrMapOvr>
+</p:sld>
+</file>
+
+<file path=ppt/slides/slide21.xml><?xml version="1.0" encoding="utf-8"?>
+<p:sld xmlns:a="http://schemas.openxmlformats.org/drawingml/2006/main" xmlns:r="http://schemas.openxmlformats.org/officeDocument/2006/relationships" xmlns:p="http://schemas.openxmlformats.org/presentationml/2006/main">
+  <p:cSld>
+    <p:bg>
+      <p:bgPr>
+        <a:solidFill>
           <a:srgbClr val="F5F7FA"/>
         </a:solidFill>
         <a:effectLst/>
@@ -27941,7 +29864,7 @@
 </p:sld>
 </file>
 
-<file path=ppt/slides/slide21.xml><?xml version="1.0" encoding="utf-8"?>
+<file path=ppt/slides/slide22.xml><?xml version="1.0" encoding="utf-8"?>
 <p:sld xmlns:a="http://schemas.openxmlformats.org/drawingml/2006/main" xmlns:r="http://schemas.openxmlformats.org/officeDocument/2006/relationships" xmlns:p="http://schemas.openxmlformats.org/presentationml/2006/main">
   <p:cSld>
     <p:bg>
@@ -29862,7 +31785,7 @@
 </p:sld>
 </file>
 
-<file path=ppt/slides/slide22.xml><?xml version="1.0" encoding="utf-8"?>
+<file path=ppt/slides/slide23.xml><?xml version="1.0" encoding="utf-8"?>
 <p:sld xmlns:a="http://schemas.openxmlformats.org/drawingml/2006/main" xmlns:r="http://schemas.openxmlformats.org/officeDocument/2006/relationships" xmlns:p="http://schemas.openxmlformats.org/presentationml/2006/main">
   <p:cSld>
     <p:bg>

</xml_diff>